<commit_message>
Switch LLM to the Gemini API (AI Studio) and local DB to SQLite; drop Docker
- New gemini provider (google-genai with an AI Studio API key), now the default
  when GEMINI_API_KEY is set; default model gemini-3.5-flash-lite.
- Retries with backoff on 408/429/5xx, optional client-side RPM limit
  (GEMINI_RPM) for the free tier, thinking level setting.
- Local database defaults to a SQLite file under var/ (WAL); Cloud SQL stays
  for deployment. Removed docker-compose and initdb.
- deploy.sh can store GEMINI_API_KEY in Secret Manager; otherwise Vertex AI.
- Assistant strips stray control characters from model output.
- README and deck re-measured on Gemini: savings 3.78L / 1.84L vs static /
  tuned rule (120/120 futures), extraction F1 0.966, WAPE 21.5% vs 23.0%,
  assistant 6/6 checked; model comparison now has 11 models.
</commit_message>
<xml_diff>
--- a/docs/Inventory_Rescue_AI_Builder_Cup.pptx
+++ b/docs/Inventory_Rescue_AI_Builder_Cup.pptx
@@ -445,10 +445,10 @@
                 <c:formatCode>General</c:formatCode>
                 <c:ptCount val="2"/>
                 <c:pt idx="0">
-                  <c:v>26.44</c:v>
+                  <c:v>26.59</c:v>
                 </c:pt>
                 <c:pt idx="1">
-                  <c:v>28.03</c:v>
+                  <c:v>28.13</c:v>
                 </c:pt>
               </c:numCache>
             </c:numRef>
@@ -7865,7 +7865,7 @@
                           <a:cs typeface="Google Sans Flex"/>
                           <a:sym typeface="Google Sans Flex"/>
                         </a:rPr>
-                        <a:t>Gemini 2.5 Flash on Vertex AI: ~10M input + 1M output tokens</a:t>
+                        <a:t>Gemini 3.5 Flash-Lite (Gemini API): ~10M input + 1M output tokens</a:t>
                       </a:r>
                     </a:p>
                   </a:txBody>
@@ -8520,7 +8520,7 @@
                 <a:cs typeface="Google Sans Flex"/>
                 <a:sym typeface="Google Sans Flex"/>
               </a:rPr>
-              <a:t>Simulated loss avoided for the demo brand (₹4.3 crore revenue a month): ₹1.7–4.1 lakh a month.</a:t>
+              <a:t>Simulated loss avoided for the demo brand (₹4.3 crore revenue a month): ₹1.6–4.0 lakh a month.</a:t>
             </a:r>
           </a:p>
           <a:p>
@@ -8543,7 +8543,7 @@
                 <a:cs typeface="Google Sans Flex"/>
                 <a:sym typeface="Google Sans Flex"/>
               </a:rPr>
-              <a:t>≈ 12–40× the running cost. At a twentieth of this size (≈ ₹2.6 crore a year) a dedicated instance only breaks even, so small brands should share one.</a:t>
+              <a:t>≈ 11–38× the running cost. At a twentieth of this size (≈ ₹2.6 crore a year) a dedicated instance only breaks even, so small brands should share one.</a:t>
             </a:r>
           </a:p>
         </p:txBody>
@@ -9237,7 +9237,7 @@
                 <a:cs typeface="Google Sans Flex"/>
                 <a:sym typeface="Google Sans Flex"/>
               </a:rPr>
-              <a:t>Every policy starts from the same stock and budget and faces the same simulated demand and supplier delays. Fill rate 90.2% vs 88.6–88.8% for the rules; hero-SKU fill 80.3% vs 75.2%.</a:t>
+              <a:t>Every policy starts from the same stock and budget and faces the same simulated demand and supplier delays. Fill rate 89.7% vs 88.6–88.8% for the rules; hero-SKU fill 80.3% vs 75.2%.</a:t>
             </a:r>
           </a:p>
           <a:p>
@@ -9268,7 +9268,7 @@
                 <a:cs typeface="Google Sans Flex"/>
                 <a:sym typeface="Google Sans Flex"/>
               </a:rPr>
-              <a:t> 151 automated tests pass · 30 / 30 seed forecasts passed LLM validation · every LLM call logged with its status.</a:t>
+              <a:t> 154 automated tests pass · 30 / 30 seed forecasts passed LLM validation · every LLM call logged with its status.</a:t>
             </a:r>
           </a:p>
         </p:txBody>
@@ -9404,7 +9404,7 @@
                 <a:cs typeface="Google Sans Flex"/>
                 <a:sym typeface="Google Sans Flex"/>
               </a:rPr>
-              <a:t>₹3.9 lakh / ₹1.9 lakh a month lower loss</a:t>
+              <a:t>₹3.8 lakh / ₹1.8 lakh a month lower loss</a:t>
             </a:r>
           </a:p>
           <a:p>
@@ -9559,7 +9559,7 @@
                 <a:cs typeface="Google Sans Flex"/>
                 <a:sym typeface="Google Sans Flex"/>
               </a:rPr>
-              <a:t>30% reserve: ₹0.8–1.0 lakh further gain</a:t>
+              <a:t>30% reserve: ₹0.9–1.1 lakh further gain</a:t>
             </a:r>
           </a:p>
           <a:p>
@@ -9888,7 +9888,7 @@
                 <a:cs typeface="Google Sans Flex"/>
                 <a:sym typeface="Google Sans Flex"/>
               </a:rPr>
-              <a:t>Hybrid vs statistical, 1,050 points (21.9% vs 24.2% on 15 text-only series)</a:t>
+              <a:t>Hybrid vs statistical, 1,050 points (22.2% vs 23.9% on 16 text-only series)</a:t>
             </a:r>
           </a:p>
         </p:txBody>
@@ -10043,7 +10043,7 @@
                 <a:cs typeface="Google Sans Flex"/>
                 <a:sym typeface="Google Sans Flex"/>
               </a:rPr>
-              <a:t>5 on the first try, 1 after one repair; 4–8 s each (gpt-5.4-mini)</a:t>
+              <a:t>5 on the first try, 1 after one repair; 3–10 s each (gemini-3.5-flash-lite)</a:t>
             </a:r>
           </a:p>
         </p:txBody>
@@ -10651,7 +10651,7 @@
                 <a:cs typeface="Google Sans Flex"/>
                 <a:sym typeface="Google Sans Flex"/>
               </a:rPr>
-              <a:t>Run the same evaluations on Gemini; route each task to its best model.</a:t>
+              <a:t>Benchmark larger Gemini models on a paid key; route each task to its best model.</a:t>
             </a:r>
           </a:p>
           <a:p>
@@ -11808,7 +11808,7 @@
                 <a:cs typeface="Google Sans Flex Medium"/>
                 <a:sym typeface="Google Sans Flex Medium"/>
               </a:rPr>
-              <a:t>Which LLM? The same evaluations on 10 models</a:t>
+              <a:t>Which LLM? The same evaluations on 11 models</a:t>
             </a:r>
             <a:endParaRPr sz="1600">
               <a:latin typeface="Google Sans Flex Medium"/>
@@ -11847,7 +11847,7 @@
                 <a:gridCol w="1143000"/>
                 <a:gridCol w="960120"/>
               </a:tblGrid>
-              <a:tr h="274320">
+              <a:tr h="251460">
                 <a:tc>
                   <a:txBody>
                     <a:bodyPr/>
@@ -12089,7 +12089,7 @@
                   </a:tcPr>
                 </a:tc>
               </a:tr>
-              <a:tr h="274320">
+              <a:tr h="251460">
                 <a:tc>
                   <a:txBody>
                     <a:bodyPr/>
@@ -12110,7 +12110,7 @@
                           <a:cs typeface="Google Sans Flex"/>
                           <a:sym typeface="Google Sans Flex"/>
                         </a:rPr>
-                        <a:t>gpt-5.4-mini (default)</a:t>
+                        <a:t>gemini-3.5-flash-lite (default)</a:t>
                       </a:r>
                     </a:p>
                   </a:txBody>
@@ -12140,7 +12140,7 @@
                           <a:cs typeface="Google Sans Flex"/>
                           <a:sym typeface="Google Sans Flex"/>
                         </a:rPr>
-                        <a:t>0.968</a:t>
+                        <a:t>0.966</a:t>
                       </a:r>
                     </a:p>
                   </a:txBody>
@@ -12230,7 +12230,7 @@
                           <a:cs typeface="Google Sans Flex"/>
                           <a:sym typeface="Google Sans Flex"/>
                         </a:rPr>
-                        <a:t>21.5% (23.1%)</a:t>
+                        <a:t>21.5% (23.0%)</a:t>
                       </a:r>
                     </a:p>
                   </a:txBody>
@@ -12260,7 +12260,7 @@
                           <a:cs typeface="Google Sans Flex"/>
                           <a:sym typeface="Google Sans Flex"/>
                         </a:rPr>
-                        <a:t>21.9% (24.2%)</a:t>
+                        <a:t>22.2% (23.9%)</a:t>
                       </a:r>
                     </a:p>
                   </a:txBody>
@@ -12320,7 +12320,7 @@
                           <a:cs typeface="Google Sans Flex"/>
                           <a:sym typeface="Google Sans Flex"/>
                         </a:rPr>
-                        <a:t>3.9 s</a:t>
+                        <a:t>4.0 s</a:t>
                       </a:r>
                     </a:p>
                   </a:txBody>
@@ -12331,7 +12331,7 @@
                   </a:tcPr>
                 </a:tc>
               </a:tr>
-              <a:tr h="274320">
+              <a:tr h="251460">
                 <a:tc>
                   <a:txBody>
                     <a:bodyPr/>
@@ -12573,7 +12573,7 @@
                   </a:tcPr>
                 </a:tc>
               </a:tr>
-              <a:tr h="274320">
+              <a:tr h="251460">
                 <a:tc>
                   <a:txBody>
                     <a:bodyPr/>
@@ -12815,7 +12815,7 @@
                   </a:tcPr>
                 </a:tc>
               </a:tr>
-              <a:tr h="274320">
+              <a:tr h="251460">
                 <a:tc>
                   <a:txBody>
                     <a:bodyPr/>
@@ -13057,7 +13057,7 @@
                   </a:tcPr>
                 </a:tc>
               </a:tr>
-              <a:tr h="274320">
+              <a:tr h="251460">
                 <a:tc>
                   <a:txBody>
                     <a:bodyPr/>
@@ -13299,7 +13299,7 @@
                   </a:tcPr>
                 </a:tc>
               </a:tr>
-              <a:tr h="274320">
+              <a:tr h="251460">
                 <a:tc>
                   <a:txBody>
                     <a:bodyPr/>
@@ -13541,7 +13541,7 @@
                   </a:tcPr>
                 </a:tc>
               </a:tr>
-              <a:tr h="274320">
+              <a:tr h="251460">
                 <a:tc>
                   <a:txBody>
                     <a:bodyPr/>
@@ -13783,7 +13783,7 @@
                   </a:tcPr>
                 </a:tc>
               </a:tr>
-              <a:tr h="274320">
+              <a:tr h="251460">
                 <a:tc>
                   <a:txBody>
                     <a:bodyPr/>
@@ -14025,7 +14025,7 @@
                   </a:tcPr>
                 </a:tc>
               </a:tr>
-              <a:tr h="274320">
+              <a:tr h="251460">
                 <a:tc>
                   <a:txBody>
                     <a:bodyPr/>
@@ -14267,7 +14267,7 @@
                   </a:tcPr>
                 </a:tc>
               </a:tr>
-              <a:tr h="274320">
+              <a:tr h="251460">
                 <a:tc>
                   <a:txBody>
                     <a:bodyPr/>
@@ -14509,6 +14509,248 @@
                   </a:tcPr>
                 </a:tc>
               </a:tr>
+              <a:tr h="251460">
+                <a:tc>
+                  <a:txBody>
+                    <a:bodyPr/>
+                    <a:lstStyle/>
+                    <a:p>
+                      <a:pPr>
+                        <a:spcAft>
+                          <a:spcPts val="200"/>
+                        </a:spcAft>
+                      </a:pPr>
+                      <a:r>
+                        <a:rPr sz="850" b="1" i="0">
+                          <a:solidFill>
+                            <a:srgbClr val="202124"/>
+                          </a:solidFill>
+                          <a:latin typeface="Google Sans Flex"/>
+                          <a:ea typeface="Google Sans Flex"/>
+                          <a:cs typeface="Google Sans Flex"/>
+                          <a:sym typeface="Google Sans Flex"/>
+                        </a:rPr>
+                        <a:t>gpt-5.4-mini</a:t>
+                      </a:r>
+                    </a:p>
+                  </a:txBody>
+                  <a:tcPr marL="45720" marR="45720" marT="18288" marB="18288" anchor="ctr">
+                    <a:solidFill>
+                      <a:srgbClr val="FFFFFF"/>
+                    </a:solidFill>
+                  </a:tcPr>
+                </a:tc>
+                <a:tc>
+                  <a:txBody>
+                    <a:bodyPr/>
+                    <a:lstStyle/>
+                    <a:p>
+                      <a:pPr algn="ctr">
+                        <a:spcAft>
+                          <a:spcPts val="200"/>
+                        </a:spcAft>
+                      </a:pPr>
+                      <a:r>
+                        <a:rPr sz="850" b="0" i="0">
+                          <a:solidFill>
+                            <a:srgbClr val="202124"/>
+                          </a:solidFill>
+                          <a:latin typeface="Google Sans Flex"/>
+                          <a:ea typeface="Google Sans Flex"/>
+                          <a:cs typeface="Google Sans Flex"/>
+                          <a:sym typeface="Google Sans Flex"/>
+                        </a:rPr>
+                        <a:t>0.968</a:t>
+                      </a:r>
+                    </a:p>
+                  </a:txBody>
+                  <a:tcPr marL="45720" marR="45720" marT="18288" marB="18288" anchor="ctr">
+                    <a:solidFill>
+                      <a:srgbClr val="FFFFFF"/>
+                    </a:solidFill>
+                  </a:tcPr>
+                </a:tc>
+                <a:tc>
+                  <a:txBody>
+                    <a:bodyPr/>
+                    <a:lstStyle/>
+                    <a:p>
+                      <a:pPr algn="ctr">
+                        <a:spcAft>
+                          <a:spcPts val="200"/>
+                        </a:spcAft>
+                      </a:pPr>
+                      <a:r>
+                        <a:rPr sz="850" b="0" i="0">
+                          <a:solidFill>
+                            <a:srgbClr val="202124"/>
+                          </a:solidFill>
+                          <a:latin typeface="Google Sans Flex"/>
+                          <a:ea typeface="Google Sans Flex"/>
+                          <a:cs typeface="Google Sans Flex"/>
+                          <a:sym typeface="Google Sans Flex"/>
+                        </a:rPr>
+                        <a:t>95.0%</a:t>
+                      </a:r>
+                    </a:p>
+                  </a:txBody>
+                  <a:tcPr marL="45720" marR="45720" marT="18288" marB="18288" anchor="ctr">
+                    <a:solidFill>
+                      <a:srgbClr val="FFFFFF"/>
+                    </a:solidFill>
+                  </a:tcPr>
+                </a:tc>
+                <a:tc>
+                  <a:txBody>
+                    <a:bodyPr/>
+                    <a:lstStyle/>
+                    <a:p>
+                      <a:pPr algn="ctr">
+                        <a:spcAft>
+                          <a:spcPts val="200"/>
+                        </a:spcAft>
+                      </a:pPr>
+                      <a:r>
+                        <a:rPr sz="850" b="0" i="0">
+                          <a:solidFill>
+                            <a:srgbClr val="202124"/>
+                          </a:solidFill>
+                          <a:latin typeface="Google Sans Flex"/>
+                          <a:ea typeface="Google Sans Flex"/>
+                          <a:cs typeface="Google Sans Flex"/>
+                          <a:sym typeface="Google Sans Flex"/>
+                        </a:rPr>
+                        <a:t>100%</a:t>
+                      </a:r>
+                    </a:p>
+                  </a:txBody>
+                  <a:tcPr marL="45720" marR="45720" marT="18288" marB="18288" anchor="ctr">
+                    <a:solidFill>
+                      <a:srgbClr val="FFFFFF"/>
+                    </a:solidFill>
+                  </a:tcPr>
+                </a:tc>
+                <a:tc>
+                  <a:txBody>
+                    <a:bodyPr/>
+                    <a:lstStyle/>
+                    <a:p>
+                      <a:pPr algn="ctr">
+                        <a:spcAft>
+                          <a:spcPts val="200"/>
+                        </a:spcAft>
+                      </a:pPr>
+                      <a:r>
+                        <a:rPr sz="850" b="0" i="0">
+                          <a:solidFill>
+                            <a:srgbClr val="202124"/>
+                          </a:solidFill>
+                          <a:latin typeface="Google Sans Flex"/>
+                          <a:ea typeface="Google Sans Flex"/>
+                          <a:cs typeface="Google Sans Flex"/>
+                          <a:sym typeface="Google Sans Flex"/>
+                        </a:rPr>
+                        <a:t>21.5% (23.1%)</a:t>
+                      </a:r>
+                    </a:p>
+                  </a:txBody>
+                  <a:tcPr marL="45720" marR="45720" marT="18288" marB="18288" anchor="ctr">
+                    <a:solidFill>
+                      <a:srgbClr val="FFFFFF"/>
+                    </a:solidFill>
+                  </a:tcPr>
+                </a:tc>
+                <a:tc>
+                  <a:txBody>
+                    <a:bodyPr/>
+                    <a:lstStyle/>
+                    <a:p>
+                      <a:pPr algn="ctr">
+                        <a:spcAft>
+                          <a:spcPts val="200"/>
+                        </a:spcAft>
+                      </a:pPr>
+                      <a:r>
+                        <a:rPr sz="850" b="0" i="0">
+                          <a:solidFill>
+                            <a:srgbClr val="202124"/>
+                          </a:solidFill>
+                          <a:latin typeface="Google Sans Flex"/>
+                          <a:ea typeface="Google Sans Flex"/>
+                          <a:cs typeface="Google Sans Flex"/>
+                          <a:sym typeface="Google Sans Flex"/>
+                        </a:rPr>
+                        <a:t>21.9% (24.2%)</a:t>
+                      </a:r>
+                    </a:p>
+                  </a:txBody>
+                  <a:tcPr marL="45720" marR="45720" marT="18288" marB="18288" anchor="ctr">
+                    <a:solidFill>
+                      <a:srgbClr val="FFFFFF"/>
+                    </a:solidFill>
+                  </a:tcPr>
+                </a:tc>
+                <a:tc>
+                  <a:txBody>
+                    <a:bodyPr/>
+                    <a:lstStyle/>
+                    <a:p>
+                      <a:pPr algn="ctr">
+                        <a:spcAft>
+                          <a:spcPts val="200"/>
+                        </a:spcAft>
+                      </a:pPr>
+                      <a:r>
+                        <a:rPr sz="850" b="0" i="0">
+                          <a:solidFill>
+                            <a:srgbClr val="202124"/>
+                          </a:solidFill>
+                          <a:latin typeface="Google Sans Flex"/>
+                          <a:ea typeface="Google Sans Flex"/>
+                          <a:cs typeface="Google Sans Flex"/>
+                          <a:sym typeface="Google Sans Flex"/>
+                        </a:rPr>
+                        <a:t>6/6 (5)</a:t>
+                      </a:r>
+                    </a:p>
+                  </a:txBody>
+                  <a:tcPr marL="45720" marR="45720" marT="18288" marB="18288" anchor="ctr">
+                    <a:solidFill>
+                      <a:srgbClr val="FFFFFF"/>
+                    </a:solidFill>
+                  </a:tcPr>
+                </a:tc>
+                <a:tc>
+                  <a:txBody>
+                    <a:bodyPr/>
+                    <a:lstStyle/>
+                    <a:p>
+                      <a:pPr algn="ctr">
+                        <a:spcAft>
+                          <a:spcPts val="200"/>
+                        </a:spcAft>
+                      </a:pPr>
+                      <a:r>
+                        <a:rPr sz="850" b="0" i="0">
+                          <a:solidFill>
+                            <a:srgbClr val="202124"/>
+                          </a:solidFill>
+                          <a:latin typeface="Google Sans Flex"/>
+                          <a:ea typeface="Google Sans Flex"/>
+                          <a:cs typeface="Google Sans Flex"/>
+                          <a:sym typeface="Google Sans Flex"/>
+                        </a:rPr>
+                        <a:t>3.9 s</a:t>
+                      </a:r>
+                    </a:p>
+                  </a:txBody>
+                  <a:tcPr marL="45720" marR="45720" marT="18288" marB="18288" anchor="ctr">
+                    <a:solidFill>
+                      <a:srgbClr val="FFFFFF"/>
+                    </a:solidFill>
+                  </a:tcPr>
+                </a:tc>
+              </a:tr>
             </a:tbl>
           </a:graphicData>
         </a:graphic>
@@ -14562,7 +14804,7 @@
                 <a:cs typeface="Google Sans Flex"/>
                 <a:sym typeface="Google Sans Flex"/>
               </a:rPr>
-              <a:t> (by 2.3–4.9 pp on text-only series); extraction is near saturated (38–40 of 40 messages). gpt-5.4-mini is the default because it is 2–8× faster; a stronger model could run the overnight forecast batch.</a:t>
+              <a:t> (by 1.7–4.9 pp on text-only series); extraction is near saturated (38–40 of 40 messages). gemini-3.5-flash-lite (Gemini API) is the default: as fast as the quickest model and 6 / 6 assistant answers checked; a stronger model could run the overnight forecasts.</a:t>
             </a:r>
           </a:p>
           <a:p>
@@ -14581,7 +14823,7 @@
                 <a:cs typeface="Google Sans Flex"/>
                 <a:sym typeface="Google Sans Flex"/>
               </a:rPr>
-              <a:t>Signal value kept: share of the gold-signal plan gain kept by plans built from the model's signals (found and fixed an end-date bug: −17% → 100%). gpt-5.3-chat's gateway rejects tool calls. Gemini on Vertex AI is next; it is not on our test gateway.</a:t>
+              <a:t>Signal value kept: share of the gold-signal plan gain kept by plans built from the model's signals (found and fixed an end-date bug: −17% → 100%). gpt-5.3-chat's gateway rejects tool calls. Larger Gemini models need a paid key (free tier: 20 requests a day).</a:t>
             </a:r>
           </a:p>
         </p:txBody>
@@ -15475,7 +15717,7 @@
                 <a:cs typeface="Google Sans Flex"/>
                 <a:sym typeface="Google Sans Flex"/>
               </a:rPr>
-              <a:t>₹3.9 lakh / month</a:t>
+              <a:t>₹3.8 lakh / month</a:t>
             </a:r>
             <a:r>
               <a:rPr sz="1100" b="0" i="0">
@@ -15499,7 +15741,7 @@
                 <a:cs typeface="Google Sans Flex"/>
                 <a:sym typeface="Google Sans Flex"/>
               </a:rPr>
-              <a:t>₹1.9 lakh</a:t>
+              <a:t>₹1.8 lakh</a:t>
             </a:r>
             <a:r>
               <a:rPr sz="1100" b="0" i="0">
@@ -15570,7 +15812,7 @@
                 <a:cs typeface="Google Sans Flex"/>
                 <a:sym typeface="Google Sans Flex"/>
               </a:rPr>
-              <a:t>₹0.8–1.0 lakh</a:t>
+              <a:t>₹0.9–1.1 lakh</a:t>
             </a:r>
             <a:r>
               <a:rPr sz="1100" b="0" i="0">
@@ -16544,7 +16786,7 @@
                 <a:cs typeface="Google Sans Flex"/>
                 <a:sym typeface="Google Sans Flex"/>
               </a:rPr>
-              <a:t> extraction gold set, forecast backtest, Monte Carlo, 10-model comparison.</a:t>
+              <a:t> extraction gold set, forecast backtest, Monte Carlo, 11-model comparison.</a:t>
             </a:r>
           </a:p>
           <a:p>
@@ -16579,7 +16821,7 @@
                 <a:cs typeface="Google Sans Flex"/>
                 <a:sym typeface="Google Sans Flex"/>
               </a:rPr>
-              <a:t> Gemini on Vertex AI, Cloud Run, Cloud SQL, Cloud Storage.</a:t>
+              <a:t> Gemini API, Cloud Run, Cloud SQL, Cloud Storage.</a:t>
             </a:r>
           </a:p>
         </p:txBody>
@@ -26927,7 +27169,7 @@
                 <a:cs typeface="Google Sans Flex"/>
                 <a:sym typeface="Google Sans Flex"/>
               </a:rPr>
-              <a:t>Generative AI layer: Gemini on Vertex AI (or any OpenAI-compatible model)</a:t>
+              <a:t>Generative AI layer: Gemini API (AI Studio key) or Gemini on Vertex AI</a:t>
             </a:r>
           </a:p>
           <a:p>
@@ -27459,7 +27701,7 @@
                 <a:cs typeface="Google Sans Flex"/>
                 <a:sym typeface="Google Sans Flex"/>
               </a:rPr>
-              <a:t>OpenAI-compatible gateway  ➜  </a:t>
+              <a:t>Gemini API (AI Studio key)  ➜  </a:t>
             </a:r>
             <a:r>
               <a:rPr sz="750" b="1" i="0">
@@ -27471,7 +27713,7 @@
                 <a:cs typeface="Google Sans Flex"/>
                 <a:sym typeface="Google Sans Flex"/>
               </a:rPr>
-              <a:t>Gemini on Vertex AI</a:t>
+              <a:t>Secret Manager key / Vertex AI</a:t>
             </a:r>
           </a:p>
         </p:txBody>
@@ -27554,7 +27796,7 @@
                 <a:cs typeface="Google Sans Flex"/>
                 <a:sym typeface="Google Sans Flex"/>
               </a:rPr>
-              <a:t>PostgreSQL 16 (Docker)  ➜  </a:t>
+              <a:t>SQLite file (no server)  ➜  </a:t>
             </a:r>
             <a:r>
               <a:rPr sz="750" b="1" i="0">
@@ -27839,7 +28081,7 @@
                 <a:cs typeface="Google Sans Flex"/>
                 <a:sym typeface="Google Sans Flex"/>
               </a:rPr>
-              <a:t>Docker, deploy script  ➜  </a:t>
+              <a:t>deploy.sh (no local Docker)  ➜  </a:t>
             </a:r>
             <a:r>
               <a:rPr sz="750" b="1" i="0">
@@ -28381,7 +28623,7 @@
                           <a:cs typeface="Google Sans Flex"/>
                           <a:sym typeface="Google Sans Flex"/>
                         </a:rPr>
-                        <a:t>google-genai (Gemini) or OpenAI SDK; validated JSON tasks; tool-calling assistant</a:t>
+                        <a:t>google-genai, gemini-3.5-flash-lite via the Gemini API; validated JSON tasks; tool-calling assistant</a:t>
                       </a:r>
                     </a:p>
                   </a:txBody>
@@ -28411,7 +28653,7 @@
                           <a:cs typeface="Google Sans Flex"/>
                           <a:sym typeface="Google Sans Flex"/>
                         </a:rPr>
-                        <a:t>Gemini 2.5 Flash on Vertex AI</a:t>
+                        <a:t>Gemini API (key in Secret Manager) or Gemini on Vertex AI</a:t>
                       </a:r>
                     </a:p>
                   </a:txBody>
@@ -28565,7 +28807,7 @@
                           <a:cs typeface="Google Sans Flex"/>
                           <a:sym typeface="Google Sans Flex"/>
                         </a:rPr>
-                        <a:t>PostgreSQL 16 in Docker; local folder for uploads, exports, forecast cache</a:t>
+                        <a:t>SQLite (no database server); local folder for uploads, exports, forecast cache</a:t>
                       </a:r>
                     </a:p>
                   </a:txBody>
@@ -28657,7 +28899,7 @@
                           <a:cs typeface="Google Sans Flex"/>
                           <a:sym typeface="Google Sans Flex"/>
                         </a:rPr>
-                        <a:t>Extraction gold set, rolling backtest, Monte Carlo, 10-model comparison</a:t>
+                        <a:t>Extraction gold set, rolling backtest, Monte Carlo, 11-model comparison</a:t>
                       </a:r>
                     </a:p>
                   </a:txBody>
@@ -28749,7 +28991,7 @@
                           <a:cs typeface="Google Sans Flex"/>
                           <a:sym typeface="Google Sans Flex"/>
                         </a:rPr>
-                        <a:t>pytest (151 tests), oxlint, strict TypeScript, LLM call log</a:t>
+                        <a:t>pytest (154 tests), oxlint, strict TypeScript, LLM call log</a:t>
                       </a:r>
                     </a:p>
                   </a:txBody>

</xml_diff>

<commit_message>
Add a minimal Simple view as the default UI
Three big tasks (make my plan, read a message, ask a question) in plain
language with large text; the full dashboard stays one click away as the
Advanced view. The assistant gains a 'simple' answer style (no ids or
jargon, money in lakh) and the grounding check accepts truncated numbers.
Deck: Simple view snapshot, 158 tests.
</commit_message>
<xml_diff>
--- a/docs/Inventory_Rescue_AI_Builder_Cup.pptx
+++ b/docs/Inventory_Rescue_AI_Builder_Cup.pptx
@@ -8867,7 +8867,7 @@
       </p:sp>
       <p:pic>
         <p:nvPicPr>
-          <p:cNvPr id="140" name="Picture 139" descr="crop_2_signals.png"/>
+          <p:cNvPr id="140" name="Picture 139" descr="crop_2_simple.png"/>
           <p:cNvPicPr>
             <a:picLocks noChangeAspect="1"/>
           </p:cNvPicPr>
@@ -8881,8 +8881,8 @@
         </p:blipFill>
         <p:spPr>
           <a:xfrm>
-            <a:off x="320040" y="3516483"/>
-            <a:ext cx="4160520" cy="830873"/>
+            <a:off x="320040" y="3207866"/>
+            <a:ext cx="4160520" cy="1448106"/>
           </a:xfrm>
           <a:prstGeom prst="rect">
             <a:avLst/>
@@ -8931,7 +8931,7 @@
                 <a:cs typeface="Google Sans Flex"/>
                 <a:sym typeface="Google Sans Flex"/>
               </a:rPr>
-              <a:t>Signal Inbox: extracted events with verbatim evidence, confirmed by the operator</a:t>
+              <a:t>Simple view (default): three big buttons, the plan in plain words</a:t>
             </a:r>
           </a:p>
         </p:txBody>
@@ -9268,7 +9268,7 @@
                 <a:cs typeface="Google Sans Flex"/>
                 <a:sym typeface="Google Sans Flex"/>
               </a:rPr>
-              <a:t> 154 automated tests pass · 30 / 30 seed forecasts passed LLM validation · every LLM call logged with its status.</a:t>
+              <a:t> 158 automated tests pass · 30 / 30 seed forecasts passed LLM validation · every LLM call logged with its status.</a:t>
             </a:r>
           </a:p>
         </p:txBody>
@@ -28991,7 +28991,7 @@
                           <a:cs typeface="Google Sans Flex"/>
                           <a:sym typeface="Google Sans Flex"/>
                         </a:rPr>
-                        <a:t>pytest (154 tests), oxlint, strict TypeScript, LLM call log</a:t>
+                        <a:t>pytest (158 tests), oxlint, strict TypeScript, LLM call log</a:t>
                       </a:r>
                     </a:p>
                   </a:txBody>

</xml_diff>

<commit_message>
Simple view: choose how to buy next to the budget; sharper minimal design
The plan screen now asks 'How do you want to buy?' with four choices (all now,
in two steps, keep money aside, spend less). Each shows what is paid now, later
or kept for the typed budget, and the safest choice in the stress test is marked.
Restyled the Simple view with a neutral palette, line icons instead of emoji,
a dark primary tile and a status pill. Sale cards now explain waste, not stockout.
</commit_message>
<xml_diff>
--- a/docs/Inventory_Rescue_AI_Builder_Cup.pptx
+++ b/docs/Inventory_Rescue_AI_Builder_Cup.pptx
@@ -8881,8 +8881,8 @@
         </p:blipFill>
         <p:spPr>
           <a:xfrm>
-            <a:off x="320040" y="3207866"/>
-            <a:ext cx="4160520" cy="1448106"/>
+            <a:off x="320040" y="3157038"/>
+            <a:ext cx="4160520" cy="1549763"/>
           </a:xfrm>
           <a:prstGeom prst="rect">
             <a:avLst/>
@@ -8931,7 +8931,7 @@
                 <a:cs typeface="Google Sans Flex"/>
                 <a:sym typeface="Google Sans Flex"/>
               </a:rPr>
-              <a:t>Simple view (default): three big buttons, the plan in plain words</a:t>
+              <a:t>Simple view (default): three big buttons; budget, then how to buy</a:t>
             </a:r>
           </a:p>
         </p:txBody>

</xml_diff>

<commit_message>
Let the user choose how much money to keep aside
POST /api/plans accepts reserve_share (0.05-0.9) for the 'keep a reserve' option;
it is stored in the plan summary and reused when a plan is edited. The Simple
view shows a slider (10-70%) under 'Keep money aside' with the amounts to spend
now and keep. Test count 159.
</commit_message>
<xml_diff>
--- a/docs/Inventory_Rescue_AI_Builder_Cup.pptx
+++ b/docs/Inventory_Rescue_AI_Builder_Cup.pptx
@@ -9268,7 +9268,7 @@
                 <a:cs typeface="Google Sans Flex"/>
                 <a:sym typeface="Google Sans Flex"/>
               </a:rPr>
-              <a:t> 158 automated tests pass · 30 / 30 seed forecasts passed LLM validation · every LLM call logged with its status.</a:t>
+              <a:t> 159 automated tests pass · 30 / 30 seed forecasts passed LLM validation · every LLM call logged with its status.</a:t>
             </a:r>
           </a:p>
         </p:txBody>
@@ -28991,7 +28991,7 @@
                           <a:cs typeface="Google Sans Flex"/>
                           <a:sym typeface="Google Sans Flex"/>
                         </a:rPr>
-                        <a:t>pytest (158 tests), oxlint, strict TypeScript, LLM call log</a:t>
+                        <a:t>pytest (159 tests), oxlint, strict TypeScript, LLM call log</a:t>
                       </a:r>
                     </a:p>
                   </a:txBody>

</xml_diff>

<commit_message>
Frame tiny and tight budgets plainly
Plan summaries gain budget_guide: the cash the plan would use with no budget
limit, the cheapest purchase that helps, and the products the plan leaves
without stock. The Simple view uses it: a budget too small to buy anything now
says so ('₹20 is not enough to buy any stock; the smallest order that helps
costs about ₹42,000') instead of 'Spend ₹0 of your ₹20 / keep ₹20 aside', free
sale steps are labelled as such, products still short are listed with run-out
dates, and one click makes a plan with the amount that covers everything. The
approve button names the right list. Warns while typing a too-small budget.
</commit_message>
<xml_diff>
--- a/docs/Inventory_Rescue_AI_Builder_Cup.pptx
+++ b/docs/Inventory_Rescue_AI_Builder_Cup.pptx
@@ -9268,7 +9268,7 @@
                 <a:cs typeface="Google Sans Flex"/>
                 <a:sym typeface="Google Sans Flex"/>
               </a:rPr>
-              <a:t> 159 automated tests pass · 30 / 30 seed forecasts passed LLM validation · every LLM call logged with its status.</a:t>
+              <a:t> 160 automated tests pass · 30 / 30 seed forecasts passed LLM validation · every LLM call logged with its status.</a:t>
             </a:r>
           </a:p>
         </p:txBody>
@@ -28991,7 +28991,7 @@
                           <a:cs typeface="Google Sans Flex"/>
                           <a:sym typeface="Google Sans Flex"/>
                         </a:rPr>
-                        <a:t>pytest (159 tests), oxlint, strict TypeScript, LLM call log</a:t>
+                        <a:t>pytest (160 tests), oxlint, strict TypeScript, LLM call log</a:t>
                       </a:r>
                     </a:p>
                   </a:txBody>

</xml_diff>

<commit_message>
Gemini-only: drop the OpenAI-compatible client and non-Google model references
- Remove LiteLLM/OpenAI client, tool session, settings and the openai dependency; Gemini API or Vertex AI only.
- README: replace the multi-vendor model comparison with a Gemini results table; drop local Docker steps.
- Deck: slide 12 now shows what gemini-3.5-flash-lite adds against non-LLM baselines; 157 tests.
</commit_message>
<xml_diff>
--- a/docs/Inventory_Rescue_AI_Builder_Cup.pptx
+++ b/docs/Inventory_Rescue_AI_Builder_Cup.pptx
@@ -9268,7 +9268,7 @@
                 <a:cs typeface="Google Sans Flex"/>
                 <a:sym typeface="Google Sans Flex"/>
               </a:rPr>
-              <a:t> 160 automated tests pass · 30 / 30 seed forecasts passed LLM validation · every LLM call logged with its status.</a:t>
+              <a:t> 157 automated tests pass · 30 / 30 seed forecasts passed LLM validation · every LLM call logged with its status.</a:t>
             </a:r>
           </a:p>
         </p:txBody>
@@ -11808,7 +11808,7 @@
                 <a:cs typeface="Google Sans Flex Medium"/>
                 <a:sym typeface="Google Sans Flex Medium"/>
               </a:rPr>
-              <a:t>Which LLM? The same evaluations on 11 models</a:t>
+              <a:t>Gemini in the loop: what gemini-3.5-flash-lite adds</a:t>
             </a:r>
             <a:endParaRPr sz="1600">
               <a:latin typeface="Google Sans Flex Medium"/>
@@ -11829,7 +11829,7 @@
         </p:nvGraphicFramePr>
         <p:xfrm>
           <a:off x="320040" y="1143000"/>
-          <a:ext cx="8503920" cy="3017520"/>
+          <a:ext cx="8503920" cy="2926080"/>
         </p:xfrm>
         <a:graphic>
           <a:graphicData uri="http://schemas.openxmlformats.org/drawingml/2006/table">
@@ -11838,16 +11838,12 @@
                 <a:tableStyleId>{5C22544A-7EE6-4342-B048-85BDC9FD1C3A}</a:tableStyleId>
               </a:tblPr>
               <a:tblGrid>
-                <a:gridCol w="1325880"/>
-                <a:gridCol w="868680"/>
-                <a:gridCol w="868680"/>
-                <a:gridCol w="868680"/>
-                <a:gridCol w="1234440"/>
-                <a:gridCol w="1234440"/>
-                <a:gridCol w="1143000"/>
-                <a:gridCol w="960120"/>
+                <a:gridCol w="2240280"/>
+                <a:gridCol w="2331720"/>
+                <a:gridCol w="1828800"/>
+                <a:gridCol w="2103120"/>
               </a:tblGrid>
-              <a:tr h="251460">
+              <a:tr h="487680">
                 <a:tc>
                   <a:txBody>
                     <a:bodyPr/>
@@ -11859,7 +11855,7 @@
                         </a:spcAft>
                       </a:pPr>
                       <a:r>
-                        <a:rPr sz="800" b="1" i="0">
+                        <a:rPr sz="900" b="1" i="0">
                           <a:solidFill>
                             <a:srgbClr val="FFFFFF"/>
                           </a:solidFill>
@@ -11868,11 +11864,11 @@
                           <a:cs typeface="Google Sans Flex"/>
                           <a:sym typeface="Google Sans Flex"/>
                         </a:rPr>
-                        <a:t>Model</a:t>
+                        <a:t>Task</a:t>
                       </a:r>
                     </a:p>
                   </a:txBody>
-                  <a:tcPr marL="45720" marR="45720" marT="18288" marB="18288" anchor="ctr">
+                  <a:tcPr marL="64008" marR="64008" marT="27432" marB="27432" anchor="ctr">
                     <a:solidFill>
                       <a:srgbClr val="202124"/>
                     </a:solidFill>
@@ -11883,13 +11879,13 @@
                     <a:bodyPr/>
                     <a:lstStyle/>
                     <a:p>
-                      <a:pPr algn="ctr">
+                      <a:pPr>
                         <a:spcAft>
                           <a:spcPts val="200"/>
                         </a:spcAft>
                       </a:pPr>
                       <a:r>
-                        <a:rPr sz="800" b="1" i="0">
+                        <a:rPr sz="900" b="1" i="0">
                           <a:solidFill>
                             <a:srgbClr val="FFFFFF"/>
                           </a:solidFill>
@@ -11898,11 +11894,11 @@
                           <a:cs typeface="Google Sans Flex"/>
                           <a:sym typeface="Google Sans Flex"/>
                         </a:rPr>
-                        <a:t>Extraction F1</a:t>
+                        <a:t>With Gemini</a:t>
                       </a:r>
                     </a:p>
                   </a:txBody>
-                  <a:tcPr marL="45720" marR="45720" marT="18288" marB="18288" anchor="ctr">
+                  <a:tcPr marL="64008" marR="64008" marT="27432" marB="27432" anchor="ctr">
                     <a:solidFill>
                       <a:srgbClr val="202124"/>
                     </a:solidFill>
@@ -11913,13 +11909,13 @@
                     <a:bodyPr/>
                     <a:lstStyle/>
                     <a:p>
-                      <a:pPr algn="ctr">
+                      <a:pPr>
                         <a:spcAft>
                           <a:spcPts val="200"/>
                         </a:spcAft>
                       </a:pPr>
                       <a:r>
-                        <a:rPr sz="800" b="1" i="0">
+                        <a:rPr sz="900" b="1" i="0">
                           <a:solidFill>
                             <a:srgbClr val="FFFFFF"/>
                           </a:solidFill>
@@ -11928,11 +11924,11 @@
                           <a:cs typeface="Google Sans Flex"/>
                           <a:sym typeface="Google Sans Flex"/>
                         </a:rPr>
-                        <a:t>Messages correct</a:t>
+                        <a:t>Without the LLM</a:t>
                       </a:r>
                     </a:p>
                   </a:txBody>
-                  <a:tcPr marL="45720" marR="45720" marT="18288" marB="18288" anchor="ctr">
+                  <a:tcPr marL="64008" marR="64008" marT="27432" marB="27432" anchor="ctr">
                     <a:solidFill>
                       <a:srgbClr val="202124"/>
                     </a:solidFill>
@@ -11943,13 +11939,13 @@
                     <a:bodyPr/>
                     <a:lstStyle/>
                     <a:p>
-                      <a:pPr algn="ctr">
+                      <a:pPr>
                         <a:spcAft>
                           <a:spcPts val="200"/>
                         </a:spcAft>
                       </a:pPr>
                       <a:r>
-                        <a:rPr sz="800" b="1" i="0">
+                        <a:rPr sz="900" b="1" i="0">
                           <a:solidFill>
                             <a:srgbClr val="FFFFFF"/>
                           </a:solidFill>
@@ -11958,138 +11954,18 @@
                           <a:cs typeface="Google Sans Flex"/>
                           <a:sym typeface="Google Sans Flex"/>
                         </a:rPr>
-                        <a:t>Signal value kept</a:t>
+                        <a:t>Guardrail</a:t>
                       </a:r>
                     </a:p>
                   </a:txBody>
-                  <a:tcPr marL="45720" marR="45720" marT="18288" marB="18288" anchor="ctr">
-                    <a:solidFill>
-                      <a:srgbClr val="202124"/>
-                    </a:solidFill>
-                  </a:tcPr>
-                </a:tc>
-                <a:tc>
-                  <a:txBody>
-                    <a:bodyPr/>
-                    <a:lstStyle/>
-                    <a:p>
-                      <a:pPr algn="ctr">
-                        <a:spcAft>
-                          <a:spcPts val="200"/>
-                        </a:spcAft>
-                      </a:pPr>
-                      <a:r>
-                        <a:rPr sz="800" b="1" i="0">
-                          <a:solidFill>
-                            <a:srgbClr val="FFFFFF"/>
-                          </a:solidFill>
-                          <a:latin typeface="Google Sans Flex"/>
-                          <a:ea typeface="Google Sans Flex"/>
-                          <a:cs typeface="Google Sans Flex"/>
-                          <a:sym typeface="Google Sans Flex"/>
-                        </a:rPr>
-                        <a:t>Forecast WAPE (statistical)</a:t>
-                      </a:r>
-                    </a:p>
-                  </a:txBody>
-                  <a:tcPr marL="45720" marR="45720" marT="18288" marB="18288" anchor="ctr">
-                    <a:solidFill>
-                      <a:srgbClr val="202124"/>
-                    </a:solidFill>
-                  </a:tcPr>
-                </a:tc>
-                <a:tc>
-                  <a:txBody>
-                    <a:bodyPr/>
-                    <a:lstStyle/>
-                    <a:p>
-                      <a:pPr algn="ctr">
-                        <a:spcAft>
-                          <a:spcPts val="200"/>
-                        </a:spcAft>
-                      </a:pPr>
-                      <a:r>
-                        <a:rPr sz="800" b="1" i="0">
-                          <a:solidFill>
-                            <a:srgbClr val="FFFFFF"/>
-                          </a:solidFill>
-                          <a:latin typeface="Google Sans Flex"/>
-                          <a:ea typeface="Google Sans Flex"/>
-                          <a:cs typeface="Google Sans Flex"/>
-                          <a:sym typeface="Google Sans Flex"/>
-                        </a:rPr>
-                        <a:t>Text-only WAPE (statistical)</a:t>
-                      </a:r>
-                    </a:p>
-                  </a:txBody>
-                  <a:tcPr marL="45720" marR="45720" marT="18288" marB="18288" anchor="ctr">
-                    <a:solidFill>
-                      <a:srgbClr val="202124"/>
-                    </a:solidFill>
-                  </a:tcPr>
-                </a:tc>
-                <a:tc>
-                  <a:txBody>
-                    <a:bodyPr/>
-                    <a:lstStyle/>
-                    <a:p>
-                      <a:pPr algn="ctr">
-                        <a:spcAft>
-                          <a:spcPts val="200"/>
-                        </a:spcAft>
-                      </a:pPr>
-                      <a:r>
-                        <a:rPr sz="800" b="1" i="0">
-                          <a:solidFill>
-                            <a:srgbClr val="FFFFFF"/>
-                          </a:solidFill>
-                          <a:latin typeface="Google Sans Flex"/>
-                          <a:ea typeface="Google Sans Flex"/>
-                          <a:cs typeface="Google Sans Flex"/>
-                          <a:sym typeface="Google Sans Flex"/>
-                        </a:rPr>
-                        <a:t>Assistant checked (first try)</a:t>
-                      </a:r>
-                    </a:p>
-                  </a:txBody>
-                  <a:tcPr marL="45720" marR="45720" marT="18288" marB="18288" anchor="ctr">
-                    <a:solidFill>
-                      <a:srgbClr val="202124"/>
-                    </a:solidFill>
-                  </a:tcPr>
-                </a:tc>
-                <a:tc>
-                  <a:txBody>
-                    <a:bodyPr/>
-                    <a:lstStyle/>
-                    <a:p>
-                      <a:pPr algn="ctr">
-                        <a:spcAft>
-                          <a:spcPts val="200"/>
-                        </a:spcAft>
-                      </a:pPr>
-                      <a:r>
-                        <a:rPr sz="800" b="1" i="0">
-                          <a:solidFill>
-                            <a:srgbClr val="FFFFFF"/>
-                          </a:solidFill>
-                          <a:latin typeface="Google Sans Flex"/>
-                          <a:ea typeface="Google Sans Flex"/>
-                          <a:cs typeface="Google Sans Flex"/>
-                          <a:sym typeface="Google Sans Flex"/>
-                        </a:rPr>
-                        <a:t>Assistant median</a:t>
-                      </a:r>
-                    </a:p>
-                  </a:txBody>
-                  <a:tcPr marL="45720" marR="45720" marT="18288" marB="18288" anchor="ctr">
+                  <a:tcPr marL="64008" marR="64008" marT="27432" marB="27432" anchor="ctr">
                     <a:solidFill>
                       <a:srgbClr val="202124"/>
                     </a:solidFill>
                   </a:tcPr>
                 </a:tc>
               </a:tr>
-              <a:tr h="251460">
+              <a:tr h="487680">
                 <a:tc>
                   <a:txBody>
                     <a:bodyPr/>
@@ -12110,11 +11986,41 @@
                           <a:cs typeface="Google Sans Flex"/>
                           <a:sym typeface="Google Sans Flex"/>
                         </a:rPr>
-                        <a:t>gemini-3.5-flash-lite (default)</a:t>
+                        <a:t>Read inbox messages into signals (40 labelled: email, WhatsApp, Hindi)</a:t>
                       </a:r>
                     </a:p>
                   </a:txBody>
-                  <a:tcPr marL="45720" marR="45720" marT="18288" marB="18288" anchor="ctr">
+                  <a:tcPr marL="64008" marR="64008" marT="27432" marB="27432" anchor="ctr">
+                    <a:solidFill>
+                      <a:srgbClr val="FFFFFF"/>
+                    </a:solidFill>
+                  </a:tcPr>
+                </a:tc>
+                <a:tc>
+                  <a:txBody>
+                    <a:bodyPr/>
+                    <a:lstStyle/>
+                    <a:p>
+                      <a:pPr>
+                        <a:spcAft>
+                          <a:spcPts val="200"/>
+                        </a:spcAft>
+                      </a:pPr>
+                      <a:r>
+                        <a:rPr sz="850" b="1" i="0">
+                          <a:solidFill>
+                            <a:srgbClr val="1A73E8"/>
+                          </a:solidFill>
+                          <a:latin typeface="Google Sans Flex"/>
+                          <a:ea typeface="Google Sans Flex"/>
+                          <a:cs typeface="Google Sans Flex"/>
+                          <a:sym typeface="Google Sans Flex"/>
+                        </a:rPr>
+                        <a:t>F1 0.97; 95% of messages fully correct; 0 invented events</a:t>
+                      </a:r>
+                    </a:p>
+                  </a:txBody>
+                  <a:tcPr marL="64008" marR="64008" marT="27432" marB="27432" anchor="ctr">
                     <a:solidFill>
                       <a:srgbClr val="E8F0FE"/>
                     </a:solidFill>
@@ -12125,7 +12031,7 @@
                     <a:bodyPr/>
                     <a:lstStyle/>
                     <a:p>
-                      <a:pPr algn="ctr">
+                      <a:pPr>
                         <a:spcAft>
                           <a:spcPts val="200"/>
                         </a:spcAft>
@@ -12140,13 +12046,13 @@
                           <a:cs typeface="Google Sans Flex"/>
                           <a:sym typeface="Google Sans Flex"/>
                         </a:rPr>
-                        <a:t>0.966</a:t>
+                        <a:t>Keyword rules: F1 0.65; 57.5% correct</a:t>
                       </a:r>
                     </a:p>
                   </a:txBody>
-                  <a:tcPr marL="45720" marR="45720" marT="18288" marB="18288" anchor="ctr">
+                  <a:tcPr marL="64008" marR="64008" marT="27432" marB="27432" anchor="ctr">
                     <a:solidFill>
-                      <a:srgbClr val="E8F0FE"/>
+                      <a:srgbClr val="FFFFFF"/>
                     </a:solidFill>
                   </a:tcPr>
                 </a:tc>
@@ -12155,7 +12061,7 @@
                     <a:bodyPr/>
                     <a:lstStyle/>
                     <a:p>
-                      <a:pPr algn="ctr">
+                      <a:pPr>
                         <a:spcAft>
                           <a:spcPts val="200"/>
                         </a:spcAft>
@@ -12170,168 +12076,18 @@
                           <a:cs typeface="Google Sans Flex"/>
                           <a:sym typeface="Google Sans Flex"/>
                         </a:rPr>
-                        <a:t>95.0%</a:t>
+                        <a:t>Evidence quote must appear verbatim; SKU, date and quantity checked</a:t>
                       </a:r>
                     </a:p>
                   </a:txBody>
-                  <a:tcPr marL="45720" marR="45720" marT="18288" marB="18288" anchor="ctr">
+                  <a:tcPr marL="64008" marR="64008" marT="27432" marB="27432" anchor="ctr">
                     <a:solidFill>
-                      <a:srgbClr val="E8F0FE"/>
-                    </a:solidFill>
-                  </a:tcPr>
-                </a:tc>
-                <a:tc>
-                  <a:txBody>
-                    <a:bodyPr/>
-                    <a:lstStyle/>
-                    <a:p>
-                      <a:pPr algn="ctr">
-                        <a:spcAft>
-                          <a:spcPts val="200"/>
-                        </a:spcAft>
-                      </a:pPr>
-                      <a:r>
-                        <a:rPr sz="850" b="0" i="0">
-                          <a:solidFill>
-                            <a:srgbClr val="202124"/>
-                          </a:solidFill>
-                          <a:latin typeface="Google Sans Flex"/>
-                          <a:ea typeface="Google Sans Flex"/>
-                          <a:cs typeface="Google Sans Flex"/>
-                          <a:sym typeface="Google Sans Flex"/>
-                        </a:rPr>
-                        <a:t>100%</a:t>
-                      </a:r>
-                    </a:p>
-                  </a:txBody>
-                  <a:tcPr marL="45720" marR="45720" marT="18288" marB="18288" anchor="ctr">
-                    <a:solidFill>
-                      <a:srgbClr val="E8F0FE"/>
-                    </a:solidFill>
-                  </a:tcPr>
-                </a:tc>
-                <a:tc>
-                  <a:txBody>
-                    <a:bodyPr/>
-                    <a:lstStyle/>
-                    <a:p>
-                      <a:pPr algn="ctr">
-                        <a:spcAft>
-                          <a:spcPts val="200"/>
-                        </a:spcAft>
-                      </a:pPr>
-                      <a:r>
-                        <a:rPr sz="850" b="0" i="0">
-                          <a:solidFill>
-                            <a:srgbClr val="202124"/>
-                          </a:solidFill>
-                          <a:latin typeface="Google Sans Flex"/>
-                          <a:ea typeface="Google Sans Flex"/>
-                          <a:cs typeface="Google Sans Flex"/>
-                          <a:sym typeface="Google Sans Flex"/>
-                        </a:rPr>
-                        <a:t>21.5% (23.0%)</a:t>
-                      </a:r>
-                    </a:p>
-                  </a:txBody>
-                  <a:tcPr marL="45720" marR="45720" marT="18288" marB="18288" anchor="ctr">
-                    <a:solidFill>
-                      <a:srgbClr val="E8F0FE"/>
-                    </a:solidFill>
-                  </a:tcPr>
-                </a:tc>
-                <a:tc>
-                  <a:txBody>
-                    <a:bodyPr/>
-                    <a:lstStyle/>
-                    <a:p>
-                      <a:pPr algn="ctr">
-                        <a:spcAft>
-                          <a:spcPts val="200"/>
-                        </a:spcAft>
-                      </a:pPr>
-                      <a:r>
-                        <a:rPr sz="850" b="0" i="0">
-                          <a:solidFill>
-                            <a:srgbClr val="202124"/>
-                          </a:solidFill>
-                          <a:latin typeface="Google Sans Flex"/>
-                          <a:ea typeface="Google Sans Flex"/>
-                          <a:cs typeface="Google Sans Flex"/>
-                          <a:sym typeface="Google Sans Flex"/>
-                        </a:rPr>
-                        <a:t>22.2% (23.9%)</a:t>
-                      </a:r>
-                    </a:p>
-                  </a:txBody>
-                  <a:tcPr marL="45720" marR="45720" marT="18288" marB="18288" anchor="ctr">
-                    <a:solidFill>
-                      <a:srgbClr val="E8F0FE"/>
-                    </a:solidFill>
-                  </a:tcPr>
-                </a:tc>
-                <a:tc>
-                  <a:txBody>
-                    <a:bodyPr/>
-                    <a:lstStyle/>
-                    <a:p>
-                      <a:pPr algn="ctr">
-                        <a:spcAft>
-                          <a:spcPts val="200"/>
-                        </a:spcAft>
-                      </a:pPr>
-                      <a:r>
-                        <a:rPr sz="850" b="0" i="0">
-                          <a:solidFill>
-                            <a:srgbClr val="202124"/>
-                          </a:solidFill>
-                          <a:latin typeface="Google Sans Flex"/>
-                          <a:ea typeface="Google Sans Flex"/>
-                          <a:cs typeface="Google Sans Flex"/>
-                          <a:sym typeface="Google Sans Flex"/>
-                        </a:rPr>
-                        <a:t>6/6 (5)</a:t>
-                      </a:r>
-                    </a:p>
-                  </a:txBody>
-                  <a:tcPr marL="45720" marR="45720" marT="18288" marB="18288" anchor="ctr">
-                    <a:solidFill>
-                      <a:srgbClr val="E8F0FE"/>
-                    </a:solidFill>
-                  </a:tcPr>
-                </a:tc>
-                <a:tc>
-                  <a:txBody>
-                    <a:bodyPr/>
-                    <a:lstStyle/>
-                    <a:p>
-                      <a:pPr algn="ctr">
-                        <a:spcAft>
-                          <a:spcPts val="200"/>
-                        </a:spcAft>
-                      </a:pPr>
-                      <a:r>
-                        <a:rPr sz="850" b="0" i="0">
-                          <a:solidFill>
-                            <a:srgbClr val="202124"/>
-                          </a:solidFill>
-                          <a:latin typeface="Google Sans Flex"/>
-                          <a:ea typeface="Google Sans Flex"/>
-                          <a:cs typeface="Google Sans Flex"/>
-                          <a:sym typeface="Google Sans Flex"/>
-                        </a:rPr>
-                        <a:t>4.0 s</a:t>
-                      </a:r>
-                    </a:p>
-                  </a:txBody>
-                  <a:tcPr marL="45720" marR="45720" marT="18288" marB="18288" anchor="ctr">
-                    <a:solidFill>
-                      <a:srgbClr val="E8F0FE"/>
+                      <a:srgbClr val="FFFFFF"/>
                     </a:solidFill>
                   </a:tcPr>
                 </a:tc>
               </a:tr>
-              <a:tr h="251460">
+              <a:tr h="487680">
                 <a:tc>
                   <a:txBody>
                     <a:bodyPr/>
@@ -12352,11 +12108,11 @@
                           <a:cs typeface="Google Sans Flex"/>
                           <a:sym typeface="Google Sans Flex"/>
                         </a:rPr>
-                        <a:t>claudesonnet4.5</a:t>
+                        <a:t>Use those signals in a ₹10 lakh plan</a:t>
                       </a:r>
                     </a:p>
                   </a:txBody>
-                  <a:tcPr marL="45720" marR="45720" marT="18288" marB="18288" anchor="ctr">
+                  <a:tcPr marL="64008" marR="64008" marT="27432" marB="27432" anchor="ctr">
                     <a:solidFill>
                       <a:srgbClr val="F1F3F4"/>
                     </a:solidFill>
@@ -12367,7 +12123,37 @@
                     <a:bodyPr/>
                     <a:lstStyle/>
                     <a:p>
-                      <a:pPr algn="ctr">
+                      <a:pPr>
+                        <a:spcAft>
+                          <a:spcPts val="200"/>
+                        </a:spcAft>
+                      </a:pPr>
+                      <a:r>
+                        <a:rPr sz="850" b="1" i="0">
+                          <a:solidFill>
+                            <a:srgbClr val="1A73E8"/>
+                          </a:solidFill>
+                          <a:latin typeface="Google Sans Flex"/>
+                          <a:ea typeface="Google Sans Flex"/>
+                          <a:cs typeface="Google Sans Flex"/>
+                          <a:sym typeface="Google Sans Flex"/>
+                        </a:rPr>
+                        <a:t>100% of the perfect-information gain (actual month and 40 worlds)</a:t>
+                      </a:r>
+                    </a:p>
+                  </a:txBody>
+                  <a:tcPr marL="64008" marR="64008" marT="27432" marB="27432" anchor="ctr">
+                    <a:solidFill>
+                      <a:srgbClr val="E8F0FE"/>
+                    </a:solidFill>
+                  </a:tcPr>
+                </a:tc>
+                <a:tc>
+                  <a:txBody>
+                    <a:bodyPr/>
+                    <a:lstStyle/>
+                    <a:p>
+                      <a:pPr>
                         <a:spcAft>
                           <a:spcPts val="200"/>
                         </a:spcAft>
@@ -12382,11 +12168,11 @@
                           <a:cs typeface="Google Sans Flex"/>
                           <a:sym typeface="Google Sans Flex"/>
                         </a:rPr>
-                        <a:t>1.000</a:t>
+                        <a:t>Hand-labelled signals = 100%</a:t>
                       </a:r>
                     </a:p>
                   </a:txBody>
-                  <a:tcPr marL="45720" marR="45720" marT="18288" marB="18288" anchor="ctr">
+                  <a:tcPr marL="64008" marR="64008" marT="27432" marB="27432" anchor="ctr">
                     <a:solidFill>
                       <a:srgbClr val="F1F3F4"/>
                     </a:solidFill>
@@ -12397,7 +12183,7 @@
                     <a:bodyPr/>
                     <a:lstStyle/>
                     <a:p>
-                      <a:pPr algn="ctr">
+                      <a:pPr>
                         <a:spcAft>
                           <a:spcPts val="200"/>
                         </a:spcAft>
@@ -12412,168 +12198,18 @@
                           <a:cs typeface="Google Sans Flex"/>
                           <a:sym typeface="Google Sans Flex"/>
                         </a:rPr>
-                        <a:t>100.0%</a:t>
+                        <a:t>A person confirms each signal before it is used</a:t>
                       </a:r>
                     </a:p>
                   </a:txBody>
-                  <a:tcPr marL="45720" marR="45720" marT="18288" marB="18288" anchor="ctr">
-                    <a:solidFill>
-                      <a:srgbClr val="F1F3F4"/>
-                    </a:solidFill>
-                  </a:tcPr>
-                </a:tc>
-                <a:tc>
-                  <a:txBody>
-                    <a:bodyPr/>
-                    <a:lstStyle/>
-                    <a:p>
-                      <a:pPr algn="ctr">
-                        <a:spcAft>
-                          <a:spcPts val="200"/>
-                        </a:spcAft>
-                      </a:pPr>
-                      <a:r>
-                        <a:rPr sz="850" b="0" i="0">
-                          <a:solidFill>
-                            <a:srgbClr val="202124"/>
-                          </a:solidFill>
-                          <a:latin typeface="Google Sans Flex"/>
-                          <a:ea typeface="Google Sans Flex"/>
-                          <a:cs typeface="Google Sans Flex"/>
-                          <a:sym typeface="Google Sans Flex"/>
-                        </a:rPr>
-                        <a:t>100%</a:t>
-                      </a:r>
-                    </a:p>
-                  </a:txBody>
-                  <a:tcPr marL="45720" marR="45720" marT="18288" marB="18288" anchor="ctr">
-                    <a:solidFill>
-                      <a:srgbClr val="F1F3F4"/>
-                    </a:solidFill>
-                  </a:tcPr>
-                </a:tc>
-                <a:tc>
-                  <a:txBody>
-                    <a:bodyPr/>
-                    <a:lstStyle/>
-                    <a:p>
-                      <a:pPr algn="ctr">
-                        <a:spcAft>
-                          <a:spcPts val="200"/>
-                        </a:spcAft>
-                      </a:pPr>
-                      <a:r>
-                        <a:rPr sz="850" b="0" i="0">
-                          <a:solidFill>
-                            <a:srgbClr val="202124"/>
-                          </a:solidFill>
-                          <a:latin typeface="Google Sans Flex"/>
-                          <a:ea typeface="Google Sans Flex"/>
-                          <a:cs typeface="Google Sans Flex"/>
-                          <a:sym typeface="Google Sans Flex"/>
-                        </a:rPr>
-                        <a:t>20.9% (23.0%)</a:t>
-                      </a:r>
-                    </a:p>
-                  </a:txBody>
-                  <a:tcPr marL="45720" marR="45720" marT="18288" marB="18288" anchor="ctr">
-                    <a:solidFill>
-                      <a:srgbClr val="F1F3F4"/>
-                    </a:solidFill>
-                  </a:tcPr>
-                </a:tc>
-                <a:tc>
-                  <a:txBody>
-                    <a:bodyPr/>
-                    <a:lstStyle/>
-                    <a:p>
-                      <a:pPr algn="ctr">
-                        <a:spcAft>
-                          <a:spcPts val="200"/>
-                        </a:spcAft>
-                      </a:pPr>
-                      <a:r>
-                        <a:rPr sz="850" b="1" i="0">
-                          <a:solidFill>
-                            <a:srgbClr val="202124"/>
-                          </a:solidFill>
-                          <a:latin typeface="Google Sans Flex"/>
-                          <a:ea typeface="Google Sans Flex"/>
-                          <a:cs typeface="Google Sans Flex"/>
-                          <a:sym typeface="Google Sans Flex"/>
-                        </a:rPr>
-                        <a:t>19.0% (23.9%)</a:t>
-                      </a:r>
-                    </a:p>
-                  </a:txBody>
-                  <a:tcPr marL="45720" marR="45720" marT="18288" marB="18288" anchor="ctr">
-                    <a:solidFill>
-                      <a:srgbClr val="F1F3F4"/>
-                    </a:solidFill>
-                  </a:tcPr>
-                </a:tc>
-                <a:tc>
-                  <a:txBody>
-                    <a:bodyPr/>
-                    <a:lstStyle/>
-                    <a:p>
-                      <a:pPr algn="ctr">
-                        <a:spcAft>
-                          <a:spcPts val="200"/>
-                        </a:spcAft>
-                      </a:pPr>
-                      <a:r>
-                        <a:rPr sz="850" b="0" i="0">
-                          <a:solidFill>
-                            <a:srgbClr val="202124"/>
-                          </a:solidFill>
-                          <a:latin typeface="Google Sans Flex"/>
-                          <a:ea typeface="Google Sans Flex"/>
-                          <a:cs typeface="Google Sans Flex"/>
-                          <a:sym typeface="Google Sans Flex"/>
-                        </a:rPr>
-                        <a:t>5/6 (5)</a:t>
-                      </a:r>
-                    </a:p>
-                  </a:txBody>
-                  <a:tcPr marL="45720" marR="45720" marT="18288" marB="18288" anchor="ctr">
-                    <a:solidFill>
-                      <a:srgbClr val="F1F3F4"/>
-                    </a:solidFill>
-                  </a:tcPr>
-                </a:tc>
-                <a:tc>
-                  <a:txBody>
-                    <a:bodyPr/>
-                    <a:lstStyle/>
-                    <a:p>
-                      <a:pPr algn="ctr">
-                        <a:spcAft>
-                          <a:spcPts val="200"/>
-                        </a:spcAft>
-                      </a:pPr>
-                      <a:r>
-                        <a:rPr sz="850" b="0" i="0">
-                          <a:solidFill>
-                            <a:srgbClr val="202124"/>
-                          </a:solidFill>
-                          <a:latin typeface="Google Sans Flex"/>
-                          <a:ea typeface="Google Sans Flex"/>
-                          <a:cs typeface="Google Sans Flex"/>
-                          <a:sym typeface="Google Sans Flex"/>
-                        </a:rPr>
-                        <a:t>10.3 s</a:t>
-                      </a:r>
-                    </a:p>
-                  </a:txBody>
-                  <a:tcPr marL="45720" marR="45720" marT="18288" marB="18288" anchor="ctr">
+                  <a:tcPr marL="64008" marR="64008" marT="27432" marB="27432" anchor="ctr">
                     <a:solidFill>
                       <a:srgbClr val="F1F3F4"/>
                     </a:solidFill>
                   </a:tcPr>
                 </a:tc>
               </a:tr>
-              <a:tr h="251460">
+              <a:tr h="487680">
                 <a:tc>
                   <a:txBody>
                     <a:bodyPr/>
@@ -12594,11 +12230,11 @@
                           <a:cs typeface="Google Sans Flex"/>
                           <a:sym typeface="Google Sans Flex"/>
                         </a:rPr>
-                        <a:t>gpt-5</a:t>
+                        <a:t>Tune event effects in the forecast (25 SKUs, 1,050 points)</a:t>
                       </a:r>
                     </a:p>
                   </a:txBody>
-                  <a:tcPr marL="45720" marR="45720" marT="18288" marB="18288" anchor="ctr">
+                  <a:tcPr marL="64008" marR="64008" marT="27432" marB="27432" anchor="ctr">
                     <a:solidFill>
                       <a:srgbClr val="FFFFFF"/>
                     </a:solidFill>
@@ -12609,7 +12245,37 @@
                     <a:bodyPr/>
                     <a:lstStyle/>
                     <a:p>
-                      <a:pPr algn="ctr">
+                      <a:pPr>
+                        <a:spcAft>
+                          <a:spcPts val="200"/>
+                        </a:spcAft>
+                      </a:pPr>
+                      <a:r>
+                        <a:rPr sz="850" b="1" i="0">
+                          <a:solidFill>
+                            <a:srgbClr val="1A73E8"/>
+                          </a:solidFill>
+                          <a:latin typeface="Google Sans Flex"/>
+                          <a:ea typeface="Google Sans Flex"/>
+                          <a:cs typeface="Google Sans Flex"/>
+                          <a:sym typeface="Google Sans Flex"/>
+                        </a:rPr>
+                        <a:t>WAPE 21.5%; P10–P90 coverage 76%</a:t>
+                      </a:r>
+                    </a:p>
+                  </a:txBody>
+                  <a:tcPr marL="64008" marR="64008" marT="27432" marB="27432" anchor="ctr">
+                    <a:solidFill>
+                      <a:srgbClr val="E8F0FE"/>
+                    </a:solidFill>
+                  </a:tcPr>
+                </a:tc>
+                <a:tc>
+                  <a:txBody>
+                    <a:bodyPr/>
+                    <a:lstStyle/>
+                    <a:p>
+                      <a:pPr>
                         <a:spcAft>
                           <a:spcPts val="200"/>
                         </a:spcAft>
@@ -12624,11 +12290,11 @@
                           <a:cs typeface="Google Sans Flex"/>
                           <a:sym typeface="Google Sans Flex"/>
                         </a:rPr>
-                        <a:t>0.983</a:t>
+                        <a:t>Statistical 23.0% / 75%; seasonal naive 24.1%</a:t>
                       </a:r>
                     </a:p>
                   </a:txBody>
-                  <a:tcPr marL="45720" marR="45720" marT="18288" marB="18288" anchor="ctr">
+                  <a:tcPr marL="64008" marR="64008" marT="27432" marB="27432" anchor="ctr">
                     <a:solidFill>
                       <a:srgbClr val="FFFFFF"/>
                     </a:solidFill>
@@ -12639,7 +12305,7 @@
                     <a:bodyPr/>
                     <a:lstStyle/>
                     <a:p>
-                      <a:pPr algn="ctr">
+                      <a:pPr>
                         <a:spcAft>
                           <a:spcPts val="200"/>
                         </a:spcAft>
@@ -12654,168 +12320,18 @@
                           <a:cs typeface="Google Sans Flex"/>
                           <a:sym typeface="Google Sans Flex"/>
                         </a:rPr>
-                        <a:t>97.5%</a:t>
+                        <a:t>75/75 outputs passed validation; else statistical</a:t>
                       </a:r>
                     </a:p>
                   </a:txBody>
-                  <a:tcPr marL="45720" marR="45720" marT="18288" marB="18288" anchor="ctr">
-                    <a:solidFill>
-                      <a:srgbClr val="FFFFFF"/>
-                    </a:solidFill>
-                  </a:tcPr>
-                </a:tc>
-                <a:tc>
-                  <a:txBody>
-                    <a:bodyPr/>
-                    <a:lstStyle/>
-                    <a:p>
-                      <a:pPr algn="ctr">
-                        <a:spcAft>
-                          <a:spcPts val="200"/>
-                        </a:spcAft>
-                      </a:pPr>
-                      <a:r>
-                        <a:rPr sz="850" b="0" i="0">
-                          <a:solidFill>
-                            <a:srgbClr val="202124"/>
-                          </a:solidFill>
-                          <a:latin typeface="Google Sans Flex"/>
-                          <a:ea typeface="Google Sans Flex"/>
-                          <a:cs typeface="Google Sans Flex"/>
-                          <a:sym typeface="Google Sans Flex"/>
-                        </a:rPr>
-                        <a:t>100%</a:t>
-                      </a:r>
-                    </a:p>
-                  </a:txBody>
-                  <a:tcPr marL="45720" marR="45720" marT="18288" marB="18288" anchor="ctr">
-                    <a:solidFill>
-                      <a:srgbClr val="FFFFFF"/>
-                    </a:solidFill>
-                  </a:tcPr>
-                </a:tc>
-                <a:tc>
-                  <a:txBody>
-                    <a:bodyPr/>
-                    <a:lstStyle/>
-                    <a:p>
-                      <a:pPr algn="ctr">
-                        <a:spcAft>
-                          <a:spcPts val="200"/>
-                        </a:spcAft>
-                      </a:pPr>
-                      <a:r>
-                        <a:rPr sz="850" b="0" i="0">
-                          <a:solidFill>
-                            <a:srgbClr val="202124"/>
-                          </a:solidFill>
-                          <a:latin typeface="Google Sans Flex"/>
-                          <a:ea typeface="Google Sans Flex"/>
-                          <a:cs typeface="Google Sans Flex"/>
-                          <a:sym typeface="Google Sans Flex"/>
-                        </a:rPr>
-                        <a:t>21.0% (23.2%)</a:t>
-                      </a:r>
-                    </a:p>
-                  </a:txBody>
-                  <a:tcPr marL="45720" marR="45720" marT="18288" marB="18288" anchor="ctr">
-                    <a:solidFill>
-                      <a:srgbClr val="FFFFFF"/>
-                    </a:solidFill>
-                  </a:tcPr>
-                </a:tc>
-                <a:tc>
-                  <a:txBody>
-                    <a:bodyPr/>
-                    <a:lstStyle/>
-                    <a:p>
-                      <a:pPr algn="ctr">
-                        <a:spcAft>
-                          <a:spcPts val="200"/>
-                        </a:spcAft>
-                      </a:pPr>
-                      <a:r>
-                        <a:rPr sz="850" b="0" i="0">
-                          <a:solidFill>
-                            <a:srgbClr val="202124"/>
-                          </a:solidFill>
-                          <a:latin typeface="Google Sans Flex"/>
-                          <a:ea typeface="Google Sans Flex"/>
-                          <a:cs typeface="Google Sans Flex"/>
-                          <a:sym typeface="Google Sans Flex"/>
-                        </a:rPr>
-                        <a:t>19.2% (23.9%)</a:t>
-                      </a:r>
-                    </a:p>
-                  </a:txBody>
-                  <a:tcPr marL="45720" marR="45720" marT="18288" marB="18288" anchor="ctr">
-                    <a:solidFill>
-                      <a:srgbClr val="FFFFFF"/>
-                    </a:solidFill>
-                  </a:tcPr>
-                </a:tc>
-                <a:tc>
-                  <a:txBody>
-                    <a:bodyPr/>
-                    <a:lstStyle/>
-                    <a:p>
-                      <a:pPr algn="ctr">
-                        <a:spcAft>
-                          <a:spcPts val="200"/>
-                        </a:spcAft>
-                      </a:pPr>
-                      <a:r>
-                        <a:rPr sz="850" b="0" i="0">
-                          <a:solidFill>
-                            <a:srgbClr val="202124"/>
-                          </a:solidFill>
-                          <a:latin typeface="Google Sans Flex"/>
-                          <a:ea typeface="Google Sans Flex"/>
-                          <a:cs typeface="Google Sans Flex"/>
-                          <a:sym typeface="Google Sans Flex"/>
-                        </a:rPr>
-                        <a:t>6/6 (6)</a:t>
-                      </a:r>
-                    </a:p>
-                  </a:txBody>
-                  <a:tcPr marL="45720" marR="45720" marT="18288" marB="18288" anchor="ctr">
-                    <a:solidFill>
-                      <a:srgbClr val="FFFFFF"/>
-                    </a:solidFill>
-                  </a:tcPr>
-                </a:tc>
-                <a:tc>
-                  <a:txBody>
-                    <a:bodyPr/>
-                    <a:lstStyle/>
-                    <a:p>
-                      <a:pPr algn="ctr">
-                        <a:spcAft>
-                          <a:spcPts val="200"/>
-                        </a:spcAft>
-                      </a:pPr>
-                      <a:r>
-                        <a:rPr sz="850" b="0" i="0">
-                          <a:solidFill>
-                            <a:srgbClr val="202124"/>
-                          </a:solidFill>
-                          <a:latin typeface="Google Sans Flex"/>
-                          <a:ea typeface="Google Sans Flex"/>
-                          <a:cs typeface="Google Sans Flex"/>
-                          <a:sym typeface="Google Sans Flex"/>
-                        </a:rPr>
-                        <a:t>30.4 s</a:t>
-                      </a:r>
-                    </a:p>
-                  </a:txBody>
-                  <a:tcPr marL="45720" marR="45720" marT="18288" marB="18288" anchor="ctr">
+                  <a:tcPr marL="64008" marR="64008" marT="27432" marB="27432" anchor="ctr">
                     <a:solidFill>
                       <a:srgbClr val="FFFFFF"/>
                     </a:solidFill>
                   </a:tcPr>
                 </a:tc>
               </a:tr>
-              <a:tr h="251460">
+              <a:tr h="487680">
                 <a:tc>
                   <a:txBody>
                     <a:bodyPr/>
@@ -12836,11 +12352,11 @@
                           <a:cs typeface="Google Sans Flex"/>
                           <a:sym typeface="Google Sans Flex"/>
                         </a:rPr>
-                        <a:t>gpt-5.1</a:t>
+                        <a:t>Events known only from text (16 series)</a:t>
                       </a:r>
                     </a:p>
                   </a:txBody>
-                  <a:tcPr marL="45720" marR="45720" marT="18288" marB="18288" anchor="ctr">
+                  <a:tcPr marL="64008" marR="64008" marT="27432" marB="27432" anchor="ctr">
                     <a:solidFill>
                       <a:srgbClr val="F1F3F4"/>
                     </a:solidFill>
@@ -12851,7 +12367,37 @@
                     <a:bodyPr/>
                     <a:lstStyle/>
                     <a:p>
-                      <a:pPr algn="ctr">
+                      <a:pPr>
+                        <a:spcAft>
+                          <a:spcPts val="200"/>
+                        </a:spcAft>
+                      </a:pPr>
+                      <a:r>
+                        <a:rPr sz="850" b="1" i="0">
+                          <a:solidFill>
+                            <a:srgbClr val="1A73E8"/>
+                          </a:solidFill>
+                          <a:latin typeface="Google Sans Flex"/>
+                          <a:ea typeface="Google Sans Flex"/>
+                          <a:cs typeface="Google Sans Flex"/>
+                          <a:sym typeface="Google Sans Flex"/>
+                        </a:rPr>
+                        <a:t>WAPE 22.2%</a:t>
+                      </a:r>
+                    </a:p>
+                  </a:txBody>
+                  <a:tcPr marL="64008" marR="64008" marT="27432" marB="27432" anchor="ctr">
+                    <a:solidFill>
+                      <a:srgbClr val="E8F0FE"/>
+                    </a:solidFill>
+                  </a:tcPr>
+                </a:tc>
+                <a:tc>
+                  <a:txBody>
+                    <a:bodyPr/>
+                    <a:lstStyle/>
+                    <a:p>
+                      <a:pPr>
                         <a:spcAft>
                           <a:spcPts val="200"/>
                         </a:spcAft>
@@ -12866,11 +12412,11 @@
                           <a:cs typeface="Google Sans Flex"/>
                           <a:sym typeface="Google Sans Flex"/>
                         </a:rPr>
-                        <a:t>0.983</a:t>
+                        <a:t>Statistical 23.9%</a:t>
                       </a:r>
                     </a:p>
                   </a:txBody>
-                  <a:tcPr marL="45720" marR="45720" marT="18288" marB="18288" anchor="ctr">
+                  <a:tcPr marL="64008" marR="64008" marT="27432" marB="27432" anchor="ctr">
                     <a:solidFill>
                       <a:srgbClr val="F1F3F4"/>
                     </a:solidFill>
@@ -12881,7 +12427,7 @@
                     <a:bodyPr/>
                     <a:lstStyle/>
                     <a:p>
-                      <a:pPr algn="ctr">
+                      <a:pPr>
                         <a:spcAft>
                           <a:spcPts val="200"/>
                         </a:spcAft>
@@ -12896,168 +12442,18 @@
                           <a:cs typeface="Google Sans Flex"/>
                           <a:sym typeface="Google Sans Flex"/>
                         </a:rPr>
-                        <a:t>97.5%</a:t>
+                        <a:t>Same validators</a:t>
                       </a:r>
                     </a:p>
                   </a:txBody>
-                  <a:tcPr marL="45720" marR="45720" marT="18288" marB="18288" anchor="ctr">
-                    <a:solidFill>
-                      <a:srgbClr val="F1F3F4"/>
-                    </a:solidFill>
-                  </a:tcPr>
-                </a:tc>
-                <a:tc>
-                  <a:txBody>
-                    <a:bodyPr/>
-                    <a:lstStyle/>
-                    <a:p>
-                      <a:pPr algn="ctr">
-                        <a:spcAft>
-                          <a:spcPts val="200"/>
-                        </a:spcAft>
-                      </a:pPr>
-                      <a:r>
-                        <a:rPr sz="850" b="0" i="0">
-                          <a:solidFill>
-                            <a:srgbClr val="202124"/>
-                          </a:solidFill>
-                          <a:latin typeface="Google Sans Flex"/>
-                          <a:ea typeface="Google Sans Flex"/>
-                          <a:cs typeface="Google Sans Flex"/>
-                          <a:sym typeface="Google Sans Flex"/>
-                        </a:rPr>
-                        <a:t>100%</a:t>
-                      </a:r>
-                    </a:p>
-                  </a:txBody>
-                  <a:tcPr marL="45720" marR="45720" marT="18288" marB="18288" anchor="ctr">
-                    <a:solidFill>
-                      <a:srgbClr val="F1F3F4"/>
-                    </a:solidFill>
-                  </a:tcPr>
-                </a:tc>
-                <a:tc>
-                  <a:txBody>
-                    <a:bodyPr/>
-                    <a:lstStyle/>
-                    <a:p>
-                      <a:pPr algn="ctr">
-                        <a:spcAft>
-                          <a:spcPts val="200"/>
-                        </a:spcAft>
-                      </a:pPr>
-                      <a:r>
-                        <a:rPr sz="850" b="0" i="0">
-                          <a:solidFill>
-                            <a:srgbClr val="202124"/>
-                          </a:solidFill>
-                          <a:latin typeface="Google Sans Flex"/>
-                          <a:ea typeface="Google Sans Flex"/>
-                          <a:cs typeface="Google Sans Flex"/>
-                          <a:sym typeface="Google Sans Flex"/>
-                        </a:rPr>
-                        <a:t>20.9% (23.0%)</a:t>
-                      </a:r>
-                    </a:p>
-                  </a:txBody>
-                  <a:tcPr marL="45720" marR="45720" marT="18288" marB="18288" anchor="ctr">
-                    <a:solidFill>
-                      <a:srgbClr val="F1F3F4"/>
-                    </a:solidFill>
-                  </a:tcPr>
-                </a:tc>
-                <a:tc>
-                  <a:txBody>
-                    <a:bodyPr/>
-                    <a:lstStyle/>
-                    <a:p>
-                      <a:pPr algn="ctr">
-                        <a:spcAft>
-                          <a:spcPts val="200"/>
-                        </a:spcAft>
-                      </a:pPr>
-                      <a:r>
-                        <a:rPr sz="850" b="0" i="0">
-                          <a:solidFill>
-                            <a:srgbClr val="202124"/>
-                          </a:solidFill>
-                          <a:latin typeface="Google Sans Flex"/>
-                          <a:ea typeface="Google Sans Flex"/>
-                          <a:cs typeface="Google Sans Flex"/>
-                          <a:sym typeface="Google Sans Flex"/>
-                        </a:rPr>
-                        <a:t>19.6% (23.9%)</a:t>
-                      </a:r>
-                    </a:p>
-                  </a:txBody>
-                  <a:tcPr marL="45720" marR="45720" marT="18288" marB="18288" anchor="ctr">
-                    <a:solidFill>
-                      <a:srgbClr val="F1F3F4"/>
-                    </a:solidFill>
-                  </a:tcPr>
-                </a:tc>
-                <a:tc>
-                  <a:txBody>
-                    <a:bodyPr/>
-                    <a:lstStyle/>
-                    <a:p>
-                      <a:pPr algn="ctr">
-                        <a:spcAft>
-                          <a:spcPts val="200"/>
-                        </a:spcAft>
-                      </a:pPr>
-                      <a:r>
-                        <a:rPr sz="850" b="0" i="0">
-                          <a:solidFill>
-                            <a:srgbClr val="202124"/>
-                          </a:solidFill>
-                          <a:latin typeface="Google Sans Flex"/>
-                          <a:ea typeface="Google Sans Flex"/>
-                          <a:cs typeface="Google Sans Flex"/>
-                          <a:sym typeface="Google Sans Flex"/>
-                        </a:rPr>
-                        <a:t>6/6 (6)</a:t>
-                      </a:r>
-                    </a:p>
-                  </a:txBody>
-                  <a:tcPr marL="45720" marR="45720" marT="18288" marB="18288" anchor="ctr">
-                    <a:solidFill>
-                      <a:srgbClr val="F1F3F4"/>
-                    </a:solidFill>
-                  </a:tcPr>
-                </a:tc>
-                <a:tc>
-                  <a:txBody>
-                    <a:bodyPr/>
-                    <a:lstStyle/>
-                    <a:p>
-                      <a:pPr algn="ctr">
-                        <a:spcAft>
-                          <a:spcPts val="200"/>
-                        </a:spcAft>
-                      </a:pPr>
-                      <a:r>
-                        <a:rPr sz="850" b="0" i="0">
-                          <a:solidFill>
-                            <a:srgbClr val="202124"/>
-                          </a:solidFill>
-                          <a:latin typeface="Google Sans Flex"/>
-                          <a:ea typeface="Google Sans Flex"/>
-                          <a:cs typeface="Google Sans Flex"/>
-                          <a:sym typeface="Google Sans Flex"/>
-                        </a:rPr>
-                        <a:t>11.9 s</a:t>
-                      </a:r>
-                    </a:p>
-                  </a:txBody>
-                  <a:tcPr marL="45720" marR="45720" marT="18288" marB="18288" anchor="ctr">
+                  <a:tcPr marL="64008" marR="64008" marT="27432" marB="27432" anchor="ctr">
                     <a:solidFill>
                       <a:srgbClr val="F1F3F4"/>
                     </a:solidFill>
                   </a:tcPr>
                 </a:tc>
               </a:tr>
-              <a:tr h="251460">
+              <a:tr h="487680">
                 <a:tc>
                   <a:txBody>
                     <a:bodyPr/>
@@ -13078,11 +12474,11 @@
                           <a:cs typeface="Google Sans Flex"/>
                           <a:sym typeface="Google Sans Flex"/>
                         </a:rPr>
-                        <a:t>claudesonnet4.6</a:t>
+                        <a:t>Planning assistant with tool calls (6 questions)</a:t>
                       </a:r>
                     </a:p>
                   </a:txBody>
-                  <a:tcPr marL="45720" marR="45720" marT="18288" marB="18288" anchor="ctr">
+                  <a:tcPr marL="64008" marR="64008" marT="27432" marB="27432" anchor="ctr">
                     <a:solidFill>
                       <a:srgbClr val="FFFFFF"/>
                     </a:solidFill>
@@ -13093,7 +12489,37 @@
                     <a:bodyPr/>
                     <a:lstStyle/>
                     <a:p>
-                      <a:pPr algn="ctr">
+                      <a:pPr>
+                        <a:spcAft>
+                          <a:spcPts val="200"/>
+                        </a:spcAft>
+                      </a:pPr>
+                      <a:r>
+                        <a:rPr sz="850" b="1" i="0">
+                          <a:solidFill>
+                            <a:srgbClr val="1A73E8"/>
+                          </a:solidFill>
+                          <a:latin typeface="Google Sans Flex"/>
+                          <a:ea typeface="Google Sans Flex"/>
+                          <a:cs typeface="Google Sans Flex"/>
+                          <a:sym typeface="Google Sans Flex"/>
+                        </a:rPr>
+                        <a:t>6/6 answers number-checked (5 first try); median 4.0 s</a:t>
+                      </a:r>
+                    </a:p>
+                  </a:txBody>
+                  <a:tcPr marL="64008" marR="64008" marT="27432" marB="27432" anchor="ctr">
+                    <a:solidFill>
+                      <a:srgbClr val="E8F0FE"/>
+                    </a:solidFill>
+                  </a:tcPr>
+                </a:tc>
+                <a:tc>
+                  <a:txBody>
+                    <a:bodyPr/>
+                    <a:lstStyle/>
+                    <a:p>
+                      <a:pPr>
                         <a:spcAft>
                           <a:spcPts val="200"/>
                         </a:spcAft>
@@ -13108,11 +12534,11 @@
                           <a:cs typeface="Google Sans Flex"/>
                           <a:sym typeface="Google Sans Flex"/>
                         </a:rPr>
-                        <a:t>0.983</a:t>
+                        <a:t>Labelled summary of the tool results</a:t>
                       </a:r>
                     </a:p>
                   </a:txBody>
-                  <a:tcPr marL="45720" marR="45720" marT="18288" marB="18288" anchor="ctr">
+                  <a:tcPr marL="64008" marR="64008" marT="27432" marB="27432" anchor="ctr">
                     <a:solidFill>
                       <a:srgbClr val="FFFFFF"/>
                     </a:solidFill>
@@ -13123,7 +12549,7 @@
                     <a:bodyPr/>
                     <a:lstStyle/>
                     <a:p>
-                      <a:pPr algn="ctr">
+                      <a:pPr>
                         <a:spcAft>
                           <a:spcPts val="200"/>
                         </a:spcAft>
@@ -13138,1613 +12564,11 @@
                           <a:cs typeface="Google Sans Flex"/>
                           <a:sym typeface="Google Sans Flex"/>
                         </a:rPr>
-                        <a:t>97.5%</a:t>
+                        <a:t>Every number must come from a tool result</a:t>
                       </a:r>
                     </a:p>
                   </a:txBody>
-                  <a:tcPr marL="45720" marR="45720" marT="18288" marB="18288" anchor="ctr">
-                    <a:solidFill>
-                      <a:srgbClr val="FFFFFF"/>
-                    </a:solidFill>
-                  </a:tcPr>
-                </a:tc>
-                <a:tc>
-                  <a:txBody>
-                    <a:bodyPr/>
-                    <a:lstStyle/>
-                    <a:p>
-                      <a:pPr algn="ctr">
-                        <a:spcAft>
-                          <a:spcPts val="200"/>
-                        </a:spcAft>
-                      </a:pPr>
-                      <a:r>
-                        <a:rPr sz="850" b="0" i="0">
-                          <a:solidFill>
-                            <a:srgbClr val="202124"/>
-                          </a:solidFill>
-                          <a:latin typeface="Google Sans Flex"/>
-                          <a:ea typeface="Google Sans Flex"/>
-                          <a:cs typeface="Google Sans Flex"/>
-                          <a:sym typeface="Google Sans Flex"/>
-                        </a:rPr>
-                        <a:t>100%</a:t>
-                      </a:r>
-                    </a:p>
-                  </a:txBody>
-                  <a:tcPr marL="45720" marR="45720" marT="18288" marB="18288" anchor="ctr">
-                    <a:solidFill>
-                      <a:srgbClr val="FFFFFF"/>
-                    </a:solidFill>
-                  </a:tcPr>
-                </a:tc>
-                <a:tc>
-                  <a:txBody>
-                    <a:bodyPr/>
-                    <a:lstStyle/>
-                    <a:p>
-                      <a:pPr algn="ctr">
-                        <a:spcAft>
-                          <a:spcPts val="200"/>
-                        </a:spcAft>
-                      </a:pPr>
-                      <a:r>
-                        <a:rPr sz="850" b="0" i="0">
-                          <a:solidFill>
-                            <a:srgbClr val="202124"/>
-                          </a:solidFill>
-                          <a:latin typeface="Google Sans Flex"/>
-                          <a:ea typeface="Google Sans Flex"/>
-                          <a:cs typeface="Google Sans Flex"/>
-                          <a:sym typeface="Google Sans Flex"/>
-                        </a:rPr>
-                        <a:t>21.6% (23.0%)</a:t>
-                      </a:r>
-                    </a:p>
-                  </a:txBody>
-                  <a:tcPr marL="45720" marR="45720" marT="18288" marB="18288" anchor="ctr">
-                    <a:solidFill>
-                      <a:srgbClr val="FFFFFF"/>
-                    </a:solidFill>
-                  </a:tcPr>
-                </a:tc>
-                <a:tc>
-                  <a:txBody>
-                    <a:bodyPr/>
-                    <a:lstStyle/>
-                    <a:p>
-                      <a:pPr algn="ctr">
-                        <a:spcAft>
-                          <a:spcPts val="200"/>
-                        </a:spcAft>
-                      </a:pPr>
-                      <a:r>
-                        <a:rPr sz="850" b="0" i="0">
-                          <a:solidFill>
-                            <a:srgbClr val="202124"/>
-                          </a:solidFill>
-                          <a:latin typeface="Google Sans Flex"/>
-                          <a:ea typeface="Google Sans Flex"/>
-                          <a:cs typeface="Google Sans Flex"/>
-                          <a:sym typeface="Google Sans Flex"/>
-                        </a:rPr>
-                        <a:t>20.1% (23.9%)</a:t>
-                      </a:r>
-                    </a:p>
-                  </a:txBody>
-                  <a:tcPr marL="45720" marR="45720" marT="18288" marB="18288" anchor="ctr">
-                    <a:solidFill>
-                      <a:srgbClr val="FFFFFF"/>
-                    </a:solidFill>
-                  </a:tcPr>
-                </a:tc>
-                <a:tc>
-                  <a:txBody>
-                    <a:bodyPr/>
-                    <a:lstStyle/>
-                    <a:p>
-                      <a:pPr algn="ctr">
-                        <a:spcAft>
-                          <a:spcPts val="200"/>
-                        </a:spcAft>
-                      </a:pPr>
-                      <a:r>
-                        <a:rPr sz="850" b="0" i="0">
-                          <a:solidFill>
-                            <a:srgbClr val="202124"/>
-                          </a:solidFill>
-                          <a:latin typeface="Google Sans Flex"/>
-                          <a:ea typeface="Google Sans Flex"/>
-                          <a:cs typeface="Google Sans Flex"/>
-                          <a:sym typeface="Google Sans Flex"/>
-                        </a:rPr>
-                        <a:t>6/6 (5)</a:t>
-                      </a:r>
-                    </a:p>
-                  </a:txBody>
-                  <a:tcPr marL="45720" marR="45720" marT="18288" marB="18288" anchor="ctr">
-                    <a:solidFill>
-                      <a:srgbClr val="FFFFFF"/>
-                    </a:solidFill>
-                  </a:tcPr>
-                </a:tc>
-                <a:tc>
-                  <a:txBody>
-                    <a:bodyPr/>
-                    <a:lstStyle/>
-                    <a:p>
-                      <a:pPr algn="ctr">
-                        <a:spcAft>
-                          <a:spcPts val="200"/>
-                        </a:spcAft>
-                      </a:pPr>
-                      <a:r>
-                        <a:rPr sz="850" b="0" i="0">
-                          <a:solidFill>
-                            <a:srgbClr val="202124"/>
-                          </a:solidFill>
-                          <a:latin typeface="Google Sans Flex"/>
-                          <a:ea typeface="Google Sans Flex"/>
-                          <a:cs typeface="Google Sans Flex"/>
-                          <a:sym typeface="Google Sans Flex"/>
-                        </a:rPr>
-                        <a:t>10.3 s</a:t>
-                      </a:r>
-                    </a:p>
-                  </a:txBody>
-                  <a:tcPr marL="45720" marR="45720" marT="18288" marB="18288" anchor="ctr">
-                    <a:solidFill>
-                      <a:srgbClr val="FFFFFF"/>
-                    </a:solidFill>
-                  </a:tcPr>
-                </a:tc>
-              </a:tr>
-              <a:tr h="251460">
-                <a:tc>
-                  <a:txBody>
-                    <a:bodyPr/>
-                    <a:lstStyle/>
-                    <a:p>
-                      <a:pPr>
-                        <a:spcAft>
-                          <a:spcPts val="200"/>
-                        </a:spcAft>
-                      </a:pPr>
-                      <a:r>
-                        <a:rPr sz="850" b="1" i="0">
-                          <a:solidFill>
-                            <a:srgbClr val="202124"/>
-                          </a:solidFill>
-                          <a:latin typeface="Google Sans Flex"/>
-                          <a:ea typeface="Google Sans Flex"/>
-                          <a:cs typeface="Google Sans Flex"/>
-                          <a:sym typeface="Google Sans Flex"/>
-                        </a:rPr>
-                        <a:t>qwen3.6-27b</a:t>
-                      </a:r>
-                    </a:p>
-                  </a:txBody>
-                  <a:tcPr marL="45720" marR="45720" marT="18288" marB="18288" anchor="ctr">
-                    <a:solidFill>
-                      <a:srgbClr val="F1F3F4"/>
-                    </a:solidFill>
-                  </a:tcPr>
-                </a:tc>
-                <a:tc>
-                  <a:txBody>
-                    <a:bodyPr/>
-                    <a:lstStyle/>
-                    <a:p>
-                      <a:pPr algn="ctr">
-                        <a:spcAft>
-                          <a:spcPts val="200"/>
-                        </a:spcAft>
-                      </a:pPr>
-                      <a:r>
-                        <a:rPr sz="850" b="0" i="0">
-                          <a:solidFill>
-                            <a:srgbClr val="202124"/>
-                          </a:solidFill>
-                          <a:latin typeface="Google Sans Flex"/>
-                          <a:ea typeface="Google Sans Flex"/>
-                          <a:cs typeface="Google Sans Flex"/>
-                          <a:sym typeface="Google Sans Flex"/>
-                        </a:rPr>
-                        <a:t>0.966</a:t>
-                      </a:r>
-                    </a:p>
-                  </a:txBody>
-                  <a:tcPr marL="45720" marR="45720" marT="18288" marB="18288" anchor="ctr">
-                    <a:solidFill>
-                      <a:srgbClr val="F1F3F4"/>
-                    </a:solidFill>
-                  </a:tcPr>
-                </a:tc>
-                <a:tc>
-                  <a:txBody>
-                    <a:bodyPr/>
-                    <a:lstStyle/>
-                    <a:p>
-                      <a:pPr algn="ctr">
-                        <a:spcAft>
-                          <a:spcPts val="200"/>
-                        </a:spcAft>
-                      </a:pPr>
-                      <a:r>
-                        <a:rPr sz="850" b="0" i="0">
-                          <a:solidFill>
-                            <a:srgbClr val="202124"/>
-                          </a:solidFill>
-                          <a:latin typeface="Google Sans Flex"/>
-                          <a:ea typeface="Google Sans Flex"/>
-                          <a:cs typeface="Google Sans Flex"/>
-                          <a:sym typeface="Google Sans Flex"/>
-                        </a:rPr>
-                        <a:t>95.0%</a:t>
-                      </a:r>
-                    </a:p>
-                  </a:txBody>
-                  <a:tcPr marL="45720" marR="45720" marT="18288" marB="18288" anchor="ctr">
-                    <a:solidFill>
-                      <a:srgbClr val="F1F3F4"/>
-                    </a:solidFill>
-                  </a:tcPr>
-                </a:tc>
-                <a:tc>
-                  <a:txBody>
-                    <a:bodyPr/>
-                    <a:lstStyle/>
-                    <a:p>
-                      <a:pPr algn="ctr">
-                        <a:spcAft>
-                          <a:spcPts val="200"/>
-                        </a:spcAft>
-                      </a:pPr>
-                      <a:r>
-                        <a:rPr sz="850" b="0" i="0">
-                          <a:solidFill>
-                            <a:srgbClr val="202124"/>
-                          </a:solidFill>
-                          <a:latin typeface="Google Sans Flex"/>
-                          <a:ea typeface="Google Sans Flex"/>
-                          <a:cs typeface="Google Sans Flex"/>
-                          <a:sym typeface="Google Sans Flex"/>
-                        </a:rPr>
-                        <a:t>100%</a:t>
-                      </a:r>
-                    </a:p>
-                  </a:txBody>
-                  <a:tcPr marL="45720" marR="45720" marT="18288" marB="18288" anchor="ctr">
-                    <a:solidFill>
-                      <a:srgbClr val="F1F3F4"/>
-                    </a:solidFill>
-                  </a:tcPr>
-                </a:tc>
-                <a:tc>
-                  <a:txBody>
-                    <a:bodyPr/>
-                    <a:lstStyle/>
-                    <a:p>
-                      <a:pPr algn="ctr">
-                        <a:spcAft>
-                          <a:spcPts val="200"/>
-                        </a:spcAft>
-                      </a:pPr>
-                      <a:r>
-                        <a:rPr sz="850" b="0" i="0">
-                          <a:solidFill>
-                            <a:srgbClr val="202124"/>
-                          </a:solidFill>
-                          <a:latin typeface="Google Sans Flex"/>
-                          <a:ea typeface="Google Sans Flex"/>
-                          <a:cs typeface="Google Sans Flex"/>
-                          <a:sym typeface="Google Sans Flex"/>
-                        </a:rPr>
-                        <a:t>21.0% (23.0%)</a:t>
-                      </a:r>
-                    </a:p>
-                  </a:txBody>
-                  <a:tcPr marL="45720" marR="45720" marT="18288" marB="18288" anchor="ctr">
-                    <a:solidFill>
-                      <a:srgbClr val="F1F3F4"/>
-                    </a:solidFill>
-                  </a:tcPr>
-                </a:tc>
-                <a:tc>
-                  <a:txBody>
-                    <a:bodyPr/>
-                    <a:lstStyle/>
-                    <a:p>
-                      <a:pPr algn="ctr">
-                        <a:spcAft>
-                          <a:spcPts val="200"/>
-                        </a:spcAft>
-                      </a:pPr>
-                      <a:r>
-                        <a:rPr sz="850" b="0" i="0">
-                          <a:solidFill>
-                            <a:srgbClr val="202124"/>
-                          </a:solidFill>
-                          <a:latin typeface="Google Sans Flex"/>
-                          <a:ea typeface="Google Sans Flex"/>
-                          <a:cs typeface="Google Sans Flex"/>
-                          <a:sym typeface="Google Sans Flex"/>
-                        </a:rPr>
-                        <a:t>20.2% (23.9%)</a:t>
-                      </a:r>
-                    </a:p>
-                  </a:txBody>
-                  <a:tcPr marL="45720" marR="45720" marT="18288" marB="18288" anchor="ctr">
-                    <a:solidFill>
-                      <a:srgbClr val="F1F3F4"/>
-                    </a:solidFill>
-                  </a:tcPr>
-                </a:tc>
-                <a:tc>
-                  <a:txBody>
-                    <a:bodyPr/>
-                    <a:lstStyle/>
-                    <a:p>
-                      <a:pPr algn="ctr">
-                        <a:spcAft>
-                          <a:spcPts val="200"/>
-                        </a:spcAft>
-                      </a:pPr>
-                      <a:r>
-                        <a:rPr sz="850" b="0" i="0">
-                          <a:solidFill>
-                            <a:srgbClr val="202124"/>
-                          </a:solidFill>
-                          <a:latin typeface="Google Sans Flex"/>
-                          <a:ea typeface="Google Sans Flex"/>
-                          <a:cs typeface="Google Sans Flex"/>
-                          <a:sym typeface="Google Sans Flex"/>
-                        </a:rPr>
-                        <a:t>6/6 (5)</a:t>
-                      </a:r>
-                    </a:p>
-                  </a:txBody>
-                  <a:tcPr marL="45720" marR="45720" marT="18288" marB="18288" anchor="ctr">
-                    <a:solidFill>
-                      <a:srgbClr val="F1F3F4"/>
-                    </a:solidFill>
-                  </a:tcPr>
-                </a:tc>
-                <a:tc>
-                  <a:txBody>
-                    <a:bodyPr/>
-                    <a:lstStyle/>
-                    <a:p>
-                      <a:pPr algn="ctr">
-                        <a:spcAft>
-                          <a:spcPts val="200"/>
-                        </a:spcAft>
-                      </a:pPr>
-                      <a:r>
-                        <a:rPr sz="850" b="0" i="0">
-                          <a:solidFill>
-                            <a:srgbClr val="202124"/>
-                          </a:solidFill>
-                          <a:latin typeface="Google Sans Flex"/>
-                          <a:ea typeface="Google Sans Flex"/>
-                          <a:cs typeface="Google Sans Flex"/>
-                          <a:sym typeface="Google Sans Flex"/>
-                        </a:rPr>
-                        <a:t>8.8 s</a:t>
-                      </a:r>
-                    </a:p>
-                  </a:txBody>
-                  <a:tcPr marL="45720" marR="45720" marT="18288" marB="18288" anchor="ctr">
-                    <a:solidFill>
-                      <a:srgbClr val="F1F3F4"/>
-                    </a:solidFill>
-                  </a:tcPr>
-                </a:tc>
-              </a:tr>
-              <a:tr h="251460">
-                <a:tc>
-                  <a:txBody>
-                    <a:bodyPr/>
-                    <a:lstStyle/>
-                    <a:p>
-                      <a:pPr>
-                        <a:spcAft>
-                          <a:spcPts val="200"/>
-                        </a:spcAft>
-                      </a:pPr>
-                      <a:r>
-                        <a:rPr sz="850" b="1" i="0">
-                          <a:solidFill>
-                            <a:srgbClr val="202124"/>
-                          </a:solidFill>
-                          <a:latin typeface="Google Sans Flex"/>
-                          <a:ea typeface="Google Sans Flex"/>
-                          <a:cs typeface="Google Sans Flex"/>
-                          <a:sym typeface="Google Sans Flex"/>
-                        </a:rPr>
-                        <a:t>claudeopus5</a:t>
-                      </a:r>
-                    </a:p>
-                  </a:txBody>
-                  <a:tcPr marL="45720" marR="45720" marT="18288" marB="18288" anchor="ctr">
-                    <a:solidFill>
-                      <a:srgbClr val="FFFFFF"/>
-                    </a:solidFill>
-                  </a:tcPr>
-                </a:tc>
-                <a:tc>
-                  <a:txBody>
-                    <a:bodyPr/>
-                    <a:lstStyle/>
-                    <a:p>
-                      <a:pPr algn="ctr">
-                        <a:spcAft>
-                          <a:spcPts val="200"/>
-                        </a:spcAft>
-                      </a:pPr>
-                      <a:r>
-                        <a:rPr sz="850" b="0" i="0">
-                          <a:solidFill>
-                            <a:srgbClr val="202124"/>
-                          </a:solidFill>
-                          <a:latin typeface="Google Sans Flex"/>
-                          <a:ea typeface="Google Sans Flex"/>
-                          <a:cs typeface="Google Sans Flex"/>
-                          <a:sym typeface="Google Sans Flex"/>
-                        </a:rPr>
-                        <a:t>0.983</a:t>
-                      </a:r>
-                    </a:p>
-                  </a:txBody>
-                  <a:tcPr marL="45720" marR="45720" marT="18288" marB="18288" anchor="ctr">
-                    <a:solidFill>
-                      <a:srgbClr val="FFFFFF"/>
-                    </a:solidFill>
-                  </a:tcPr>
-                </a:tc>
-                <a:tc>
-                  <a:txBody>
-                    <a:bodyPr/>
-                    <a:lstStyle/>
-                    <a:p>
-                      <a:pPr algn="ctr">
-                        <a:spcAft>
-                          <a:spcPts val="200"/>
-                        </a:spcAft>
-                      </a:pPr>
-                      <a:r>
-                        <a:rPr sz="850" b="0" i="0">
-                          <a:solidFill>
-                            <a:srgbClr val="202124"/>
-                          </a:solidFill>
-                          <a:latin typeface="Google Sans Flex"/>
-                          <a:ea typeface="Google Sans Flex"/>
-                          <a:cs typeface="Google Sans Flex"/>
-                          <a:sym typeface="Google Sans Flex"/>
-                        </a:rPr>
-                        <a:t>97.5%</a:t>
-                      </a:r>
-                    </a:p>
-                  </a:txBody>
-                  <a:tcPr marL="45720" marR="45720" marT="18288" marB="18288" anchor="ctr">
-                    <a:solidFill>
-                      <a:srgbClr val="FFFFFF"/>
-                    </a:solidFill>
-                  </a:tcPr>
-                </a:tc>
-                <a:tc>
-                  <a:txBody>
-                    <a:bodyPr/>
-                    <a:lstStyle/>
-                    <a:p>
-                      <a:pPr algn="ctr">
-                        <a:spcAft>
-                          <a:spcPts val="200"/>
-                        </a:spcAft>
-                      </a:pPr>
-                      <a:r>
-                        <a:rPr sz="850" b="0" i="0">
-                          <a:solidFill>
-                            <a:srgbClr val="202124"/>
-                          </a:solidFill>
-                          <a:latin typeface="Google Sans Flex"/>
-                          <a:ea typeface="Google Sans Flex"/>
-                          <a:cs typeface="Google Sans Flex"/>
-                          <a:sym typeface="Google Sans Flex"/>
-                        </a:rPr>
-                        <a:t>100%</a:t>
-                      </a:r>
-                    </a:p>
-                  </a:txBody>
-                  <a:tcPr marL="45720" marR="45720" marT="18288" marB="18288" anchor="ctr">
-                    <a:solidFill>
-                      <a:srgbClr val="FFFFFF"/>
-                    </a:solidFill>
-                  </a:tcPr>
-                </a:tc>
-                <a:tc>
-                  <a:txBody>
-                    <a:bodyPr/>
-                    <a:lstStyle/>
-                    <a:p>
-                      <a:pPr algn="ctr">
-                        <a:spcAft>
-                          <a:spcPts val="200"/>
-                        </a:spcAft>
-                      </a:pPr>
-                      <a:r>
-                        <a:rPr sz="850" b="0" i="0">
-                          <a:solidFill>
-                            <a:srgbClr val="202124"/>
-                          </a:solidFill>
-                          <a:latin typeface="Google Sans Flex"/>
-                          <a:ea typeface="Google Sans Flex"/>
-                          <a:cs typeface="Google Sans Flex"/>
-                          <a:sym typeface="Google Sans Flex"/>
-                        </a:rPr>
-                        <a:t>21.3% (23.0%)</a:t>
-                      </a:r>
-                    </a:p>
-                  </a:txBody>
-                  <a:tcPr marL="45720" marR="45720" marT="18288" marB="18288" anchor="ctr">
-                    <a:solidFill>
-                      <a:srgbClr val="FFFFFF"/>
-                    </a:solidFill>
-                  </a:tcPr>
-                </a:tc>
-                <a:tc>
-                  <a:txBody>
-                    <a:bodyPr/>
-                    <a:lstStyle/>
-                    <a:p>
-                      <a:pPr algn="ctr">
-                        <a:spcAft>
-                          <a:spcPts val="200"/>
-                        </a:spcAft>
-                      </a:pPr>
-                      <a:r>
-                        <a:rPr sz="850" b="0" i="0">
-                          <a:solidFill>
-                            <a:srgbClr val="202124"/>
-                          </a:solidFill>
-                          <a:latin typeface="Google Sans Flex"/>
-                          <a:ea typeface="Google Sans Flex"/>
-                          <a:cs typeface="Google Sans Flex"/>
-                          <a:sym typeface="Google Sans Flex"/>
-                        </a:rPr>
-                        <a:t>20.2% (23.9%)</a:t>
-                      </a:r>
-                    </a:p>
-                  </a:txBody>
-                  <a:tcPr marL="45720" marR="45720" marT="18288" marB="18288" anchor="ctr">
-                    <a:solidFill>
-                      <a:srgbClr val="FFFFFF"/>
-                    </a:solidFill>
-                  </a:tcPr>
-                </a:tc>
-                <a:tc>
-                  <a:txBody>
-                    <a:bodyPr/>
-                    <a:lstStyle/>
-                    <a:p>
-                      <a:pPr algn="ctr">
-                        <a:spcAft>
-                          <a:spcPts val="200"/>
-                        </a:spcAft>
-                      </a:pPr>
-                      <a:r>
-                        <a:rPr sz="850" b="0" i="0">
-                          <a:solidFill>
-                            <a:srgbClr val="202124"/>
-                          </a:solidFill>
-                          <a:latin typeface="Google Sans Flex"/>
-                          <a:ea typeface="Google Sans Flex"/>
-                          <a:cs typeface="Google Sans Flex"/>
-                          <a:sym typeface="Google Sans Flex"/>
-                        </a:rPr>
-                        <a:t>6/6 (4)</a:t>
-                      </a:r>
-                    </a:p>
-                  </a:txBody>
-                  <a:tcPr marL="45720" marR="45720" marT="18288" marB="18288" anchor="ctr">
-                    <a:solidFill>
-                      <a:srgbClr val="FFFFFF"/>
-                    </a:solidFill>
-                  </a:tcPr>
-                </a:tc>
-                <a:tc>
-                  <a:txBody>
-                    <a:bodyPr/>
-                    <a:lstStyle/>
-                    <a:p>
-                      <a:pPr algn="ctr">
-                        <a:spcAft>
-                          <a:spcPts val="200"/>
-                        </a:spcAft>
-                      </a:pPr>
-                      <a:r>
-                        <a:rPr sz="850" b="0" i="0">
-                          <a:solidFill>
-                            <a:srgbClr val="202124"/>
-                          </a:solidFill>
-                          <a:latin typeface="Google Sans Flex"/>
-                          <a:ea typeface="Google Sans Flex"/>
-                          <a:cs typeface="Google Sans Flex"/>
-                          <a:sym typeface="Google Sans Flex"/>
-                        </a:rPr>
-                        <a:t>12.3 s</a:t>
-                      </a:r>
-                    </a:p>
-                  </a:txBody>
-                  <a:tcPr marL="45720" marR="45720" marT="18288" marB="18288" anchor="ctr">
-                    <a:solidFill>
-                      <a:srgbClr val="FFFFFF"/>
-                    </a:solidFill>
-                  </a:tcPr>
-                </a:tc>
-              </a:tr>
-              <a:tr h="251460">
-                <a:tc>
-                  <a:txBody>
-                    <a:bodyPr/>
-                    <a:lstStyle/>
-                    <a:p>
-                      <a:pPr>
-                        <a:spcAft>
-                          <a:spcPts val="200"/>
-                        </a:spcAft>
-                      </a:pPr>
-                      <a:r>
-                        <a:rPr sz="850" b="1" i="0">
-                          <a:solidFill>
-                            <a:srgbClr val="202124"/>
-                          </a:solidFill>
-                          <a:latin typeface="Google Sans Flex"/>
-                          <a:ea typeface="Google Sans Flex"/>
-                          <a:cs typeface="Google Sans Flex"/>
-                          <a:sym typeface="Google Sans Flex"/>
-                        </a:rPr>
-                        <a:t>gpt-5.6-luna</a:t>
-                      </a:r>
-                    </a:p>
-                  </a:txBody>
-                  <a:tcPr marL="45720" marR="45720" marT="18288" marB="18288" anchor="ctr">
-                    <a:solidFill>
-                      <a:srgbClr val="F1F3F4"/>
-                    </a:solidFill>
-                  </a:tcPr>
-                </a:tc>
-                <a:tc>
-                  <a:txBody>
-                    <a:bodyPr/>
-                    <a:lstStyle/>
-                    <a:p>
-                      <a:pPr algn="ctr">
-                        <a:spcAft>
-                          <a:spcPts val="200"/>
-                        </a:spcAft>
-                      </a:pPr>
-                      <a:r>
-                        <a:rPr sz="850" b="0" i="0">
-                          <a:solidFill>
-                            <a:srgbClr val="202124"/>
-                          </a:solidFill>
-                          <a:latin typeface="Google Sans Flex"/>
-                          <a:ea typeface="Google Sans Flex"/>
-                          <a:cs typeface="Google Sans Flex"/>
-                          <a:sym typeface="Google Sans Flex"/>
-                        </a:rPr>
-                        <a:t>0.983</a:t>
-                      </a:r>
-                    </a:p>
-                  </a:txBody>
-                  <a:tcPr marL="45720" marR="45720" marT="18288" marB="18288" anchor="ctr">
-                    <a:solidFill>
-                      <a:srgbClr val="F1F3F4"/>
-                    </a:solidFill>
-                  </a:tcPr>
-                </a:tc>
-                <a:tc>
-                  <a:txBody>
-                    <a:bodyPr/>
-                    <a:lstStyle/>
-                    <a:p>
-                      <a:pPr algn="ctr">
-                        <a:spcAft>
-                          <a:spcPts val="200"/>
-                        </a:spcAft>
-                      </a:pPr>
-                      <a:r>
-                        <a:rPr sz="850" b="0" i="0">
-                          <a:solidFill>
-                            <a:srgbClr val="202124"/>
-                          </a:solidFill>
-                          <a:latin typeface="Google Sans Flex"/>
-                          <a:ea typeface="Google Sans Flex"/>
-                          <a:cs typeface="Google Sans Flex"/>
-                          <a:sym typeface="Google Sans Flex"/>
-                        </a:rPr>
-                        <a:t>97.5%</a:t>
-                      </a:r>
-                    </a:p>
-                  </a:txBody>
-                  <a:tcPr marL="45720" marR="45720" marT="18288" marB="18288" anchor="ctr">
-                    <a:solidFill>
-                      <a:srgbClr val="F1F3F4"/>
-                    </a:solidFill>
-                  </a:tcPr>
-                </a:tc>
-                <a:tc>
-                  <a:txBody>
-                    <a:bodyPr/>
-                    <a:lstStyle/>
-                    <a:p>
-                      <a:pPr algn="ctr">
-                        <a:spcAft>
-                          <a:spcPts val="200"/>
-                        </a:spcAft>
-                      </a:pPr>
-                      <a:r>
-                        <a:rPr sz="850" b="0" i="0">
-                          <a:solidFill>
-                            <a:srgbClr val="202124"/>
-                          </a:solidFill>
-                          <a:latin typeface="Google Sans Flex"/>
-                          <a:ea typeface="Google Sans Flex"/>
-                          <a:cs typeface="Google Sans Flex"/>
-                          <a:sym typeface="Google Sans Flex"/>
-                        </a:rPr>
-                        <a:t>100%</a:t>
-                      </a:r>
-                    </a:p>
-                  </a:txBody>
-                  <a:tcPr marL="45720" marR="45720" marT="18288" marB="18288" anchor="ctr">
-                    <a:solidFill>
-                      <a:srgbClr val="F1F3F4"/>
-                    </a:solidFill>
-                  </a:tcPr>
-                </a:tc>
-                <a:tc>
-                  <a:txBody>
-                    <a:bodyPr/>
-                    <a:lstStyle/>
-                    <a:p>
-                      <a:pPr algn="ctr">
-                        <a:spcAft>
-                          <a:spcPts val="200"/>
-                        </a:spcAft>
-                      </a:pPr>
-                      <a:r>
-                        <a:rPr sz="850" b="0" i="0">
-                          <a:solidFill>
-                            <a:srgbClr val="202124"/>
-                          </a:solidFill>
-                          <a:latin typeface="Google Sans Flex"/>
-                          <a:ea typeface="Google Sans Flex"/>
-                          <a:cs typeface="Google Sans Flex"/>
-                          <a:sym typeface="Google Sans Flex"/>
-                        </a:rPr>
-                        <a:t>21.2% (23.0%)</a:t>
-                      </a:r>
-                    </a:p>
-                  </a:txBody>
-                  <a:tcPr marL="45720" marR="45720" marT="18288" marB="18288" anchor="ctr">
-                    <a:solidFill>
-                      <a:srgbClr val="F1F3F4"/>
-                    </a:solidFill>
-                  </a:tcPr>
-                </a:tc>
-                <a:tc>
-                  <a:txBody>
-                    <a:bodyPr/>
-                    <a:lstStyle/>
-                    <a:p>
-                      <a:pPr algn="ctr">
-                        <a:spcAft>
-                          <a:spcPts val="200"/>
-                        </a:spcAft>
-                      </a:pPr>
-                      <a:r>
-                        <a:rPr sz="850" b="0" i="0">
-                          <a:solidFill>
-                            <a:srgbClr val="202124"/>
-                          </a:solidFill>
-                          <a:latin typeface="Google Sans Flex"/>
-                          <a:ea typeface="Google Sans Flex"/>
-                          <a:cs typeface="Google Sans Flex"/>
-                          <a:sym typeface="Google Sans Flex"/>
-                        </a:rPr>
-                        <a:t>20.3% (23.9%)</a:t>
-                      </a:r>
-                    </a:p>
-                  </a:txBody>
-                  <a:tcPr marL="45720" marR="45720" marT="18288" marB="18288" anchor="ctr">
-                    <a:solidFill>
-                      <a:srgbClr val="F1F3F4"/>
-                    </a:solidFill>
-                  </a:tcPr>
-                </a:tc>
-                <a:tc>
-                  <a:txBody>
-                    <a:bodyPr/>
-                    <a:lstStyle/>
-                    <a:p>
-                      <a:pPr algn="ctr">
-                        <a:spcAft>
-                          <a:spcPts val="200"/>
-                        </a:spcAft>
-                      </a:pPr>
-                      <a:r>
-                        <a:rPr sz="850" b="0" i="0">
-                          <a:solidFill>
-                            <a:srgbClr val="202124"/>
-                          </a:solidFill>
-                          <a:latin typeface="Google Sans Flex"/>
-                          <a:ea typeface="Google Sans Flex"/>
-                          <a:cs typeface="Google Sans Flex"/>
-                          <a:sym typeface="Google Sans Flex"/>
-                        </a:rPr>
-                        <a:t>6/6 (6)</a:t>
-                      </a:r>
-                    </a:p>
-                  </a:txBody>
-                  <a:tcPr marL="45720" marR="45720" marT="18288" marB="18288" anchor="ctr">
-                    <a:solidFill>
-                      <a:srgbClr val="F1F3F4"/>
-                    </a:solidFill>
-                  </a:tcPr>
-                </a:tc>
-                <a:tc>
-                  <a:txBody>
-                    <a:bodyPr/>
-                    <a:lstStyle/>
-                    <a:p>
-                      <a:pPr algn="ctr">
-                        <a:spcAft>
-                          <a:spcPts val="200"/>
-                        </a:spcAft>
-                      </a:pPr>
-                      <a:r>
-                        <a:rPr sz="850" b="0" i="0">
-                          <a:solidFill>
-                            <a:srgbClr val="202124"/>
-                          </a:solidFill>
-                          <a:latin typeface="Google Sans Flex"/>
-                          <a:ea typeface="Google Sans Flex"/>
-                          <a:cs typeface="Google Sans Flex"/>
-                          <a:sym typeface="Google Sans Flex"/>
-                        </a:rPr>
-                        <a:t>14.8 s</a:t>
-                      </a:r>
-                    </a:p>
-                  </a:txBody>
-                  <a:tcPr marL="45720" marR="45720" marT="18288" marB="18288" anchor="ctr">
-                    <a:solidFill>
-                      <a:srgbClr val="F1F3F4"/>
-                    </a:solidFill>
-                  </a:tcPr>
-                </a:tc>
-              </a:tr>
-              <a:tr h="251460">
-                <a:tc>
-                  <a:txBody>
-                    <a:bodyPr/>
-                    <a:lstStyle/>
-                    <a:p>
-                      <a:pPr>
-                        <a:spcAft>
-                          <a:spcPts val="200"/>
-                        </a:spcAft>
-                      </a:pPr>
-                      <a:r>
-                        <a:rPr sz="850" b="1" i="0">
-                          <a:solidFill>
-                            <a:srgbClr val="202124"/>
-                          </a:solidFill>
-                          <a:latin typeface="Google Sans Flex"/>
-                          <a:ea typeface="Google Sans Flex"/>
-                          <a:cs typeface="Google Sans Flex"/>
-                          <a:sym typeface="Google Sans Flex"/>
-                        </a:rPr>
-                        <a:t>gpt-5.2</a:t>
-                      </a:r>
-                    </a:p>
-                  </a:txBody>
-                  <a:tcPr marL="45720" marR="45720" marT="18288" marB="18288" anchor="ctr">
-                    <a:solidFill>
-                      <a:srgbClr val="FFFFFF"/>
-                    </a:solidFill>
-                  </a:tcPr>
-                </a:tc>
-                <a:tc>
-                  <a:txBody>
-                    <a:bodyPr/>
-                    <a:lstStyle/>
-                    <a:p>
-                      <a:pPr algn="ctr">
-                        <a:spcAft>
-                          <a:spcPts val="200"/>
-                        </a:spcAft>
-                      </a:pPr>
-                      <a:r>
-                        <a:rPr sz="850" b="0" i="0">
-                          <a:solidFill>
-                            <a:srgbClr val="202124"/>
-                          </a:solidFill>
-                          <a:latin typeface="Google Sans Flex"/>
-                          <a:ea typeface="Google Sans Flex"/>
-                          <a:cs typeface="Google Sans Flex"/>
-                          <a:sym typeface="Google Sans Flex"/>
-                        </a:rPr>
-                        <a:t>0.983</a:t>
-                      </a:r>
-                    </a:p>
-                  </a:txBody>
-                  <a:tcPr marL="45720" marR="45720" marT="18288" marB="18288" anchor="ctr">
-                    <a:solidFill>
-                      <a:srgbClr val="FFFFFF"/>
-                    </a:solidFill>
-                  </a:tcPr>
-                </a:tc>
-                <a:tc>
-                  <a:txBody>
-                    <a:bodyPr/>
-                    <a:lstStyle/>
-                    <a:p>
-                      <a:pPr algn="ctr">
-                        <a:spcAft>
-                          <a:spcPts val="200"/>
-                        </a:spcAft>
-                      </a:pPr>
-                      <a:r>
-                        <a:rPr sz="850" b="0" i="0">
-                          <a:solidFill>
-                            <a:srgbClr val="202124"/>
-                          </a:solidFill>
-                          <a:latin typeface="Google Sans Flex"/>
-                          <a:ea typeface="Google Sans Flex"/>
-                          <a:cs typeface="Google Sans Flex"/>
-                          <a:sym typeface="Google Sans Flex"/>
-                        </a:rPr>
-                        <a:t>97.5%</a:t>
-                      </a:r>
-                    </a:p>
-                  </a:txBody>
-                  <a:tcPr marL="45720" marR="45720" marT="18288" marB="18288" anchor="ctr">
-                    <a:solidFill>
-                      <a:srgbClr val="FFFFFF"/>
-                    </a:solidFill>
-                  </a:tcPr>
-                </a:tc>
-                <a:tc>
-                  <a:txBody>
-                    <a:bodyPr/>
-                    <a:lstStyle/>
-                    <a:p>
-                      <a:pPr algn="ctr">
-                        <a:spcAft>
-                          <a:spcPts val="200"/>
-                        </a:spcAft>
-                      </a:pPr>
-                      <a:r>
-                        <a:rPr sz="850" b="0" i="0">
-                          <a:solidFill>
-                            <a:srgbClr val="202124"/>
-                          </a:solidFill>
-                          <a:latin typeface="Google Sans Flex"/>
-                          <a:ea typeface="Google Sans Flex"/>
-                          <a:cs typeface="Google Sans Flex"/>
-                          <a:sym typeface="Google Sans Flex"/>
-                        </a:rPr>
-                        <a:t>100%</a:t>
-                      </a:r>
-                    </a:p>
-                  </a:txBody>
-                  <a:tcPr marL="45720" marR="45720" marT="18288" marB="18288" anchor="ctr">
-                    <a:solidFill>
-                      <a:srgbClr val="FFFFFF"/>
-                    </a:solidFill>
-                  </a:tcPr>
-                </a:tc>
-                <a:tc>
-                  <a:txBody>
-                    <a:bodyPr/>
-                    <a:lstStyle/>
-                    <a:p>
-                      <a:pPr algn="ctr">
-                        <a:spcAft>
-                          <a:spcPts val="200"/>
-                        </a:spcAft>
-                      </a:pPr>
-                      <a:r>
-                        <a:rPr sz="850" b="0" i="0">
-                          <a:solidFill>
-                            <a:srgbClr val="202124"/>
-                          </a:solidFill>
-                          <a:latin typeface="Google Sans Flex"/>
-                          <a:ea typeface="Google Sans Flex"/>
-                          <a:cs typeface="Google Sans Flex"/>
-                          <a:sym typeface="Google Sans Flex"/>
-                        </a:rPr>
-                        <a:t>21.3% (23.0%)</a:t>
-                      </a:r>
-                    </a:p>
-                  </a:txBody>
-                  <a:tcPr marL="45720" marR="45720" marT="18288" marB="18288" anchor="ctr">
-                    <a:solidFill>
-                      <a:srgbClr val="FFFFFF"/>
-                    </a:solidFill>
-                  </a:tcPr>
-                </a:tc>
-                <a:tc>
-                  <a:txBody>
-                    <a:bodyPr/>
-                    <a:lstStyle/>
-                    <a:p>
-                      <a:pPr algn="ctr">
-                        <a:spcAft>
-                          <a:spcPts val="200"/>
-                        </a:spcAft>
-                      </a:pPr>
-                      <a:r>
-                        <a:rPr sz="850" b="0" i="0">
-                          <a:solidFill>
-                            <a:srgbClr val="202124"/>
-                          </a:solidFill>
-                          <a:latin typeface="Google Sans Flex"/>
-                          <a:ea typeface="Google Sans Flex"/>
-                          <a:cs typeface="Google Sans Flex"/>
-                          <a:sym typeface="Google Sans Flex"/>
-                        </a:rPr>
-                        <a:t>21.2% (23.9%)</a:t>
-                      </a:r>
-                    </a:p>
-                  </a:txBody>
-                  <a:tcPr marL="45720" marR="45720" marT="18288" marB="18288" anchor="ctr">
-                    <a:solidFill>
-                      <a:srgbClr val="FFFFFF"/>
-                    </a:solidFill>
-                  </a:tcPr>
-                </a:tc>
-                <a:tc>
-                  <a:txBody>
-                    <a:bodyPr/>
-                    <a:lstStyle/>
-                    <a:p>
-                      <a:pPr algn="ctr">
-                        <a:spcAft>
-                          <a:spcPts val="200"/>
-                        </a:spcAft>
-                      </a:pPr>
-                      <a:r>
-                        <a:rPr sz="850" b="0" i="0">
-                          <a:solidFill>
-                            <a:srgbClr val="202124"/>
-                          </a:solidFill>
-                          <a:latin typeface="Google Sans Flex"/>
-                          <a:ea typeface="Google Sans Flex"/>
-                          <a:cs typeface="Google Sans Flex"/>
-                          <a:sym typeface="Google Sans Flex"/>
-                        </a:rPr>
-                        <a:t>6/6 (6)</a:t>
-                      </a:r>
-                    </a:p>
-                  </a:txBody>
-                  <a:tcPr marL="45720" marR="45720" marT="18288" marB="18288" anchor="ctr">
-                    <a:solidFill>
-                      <a:srgbClr val="FFFFFF"/>
-                    </a:solidFill>
-                  </a:tcPr>
-                </a:tc>
-                <a:tc>
-                  <a:txBody>
-                    <a:bodyPr/>
-                    <a:lstStyle/>
-                    <a:p>
-                      <a:pPr algn="ctr">
-                        <a:spcAft>
-                          <a:spcPts val="200"/>
-                        </a:spcAft>
-                      </a:pPr>
-                      <a:r>
-                        <a:rPr sz="850" b="0" i="0">
-                          <a:solidFill>
-                            <a:srgbClr val="202124"/>
-                          </a:solidFill>
-                          <a:latin typeface="Google Sans Flex"/>
-                          <a:ea typeface="Google Sans Flex"/>
-                          <a:cs typeface="Google Sans Flex"/>
-                          <a:sym typeface="Google Sans Flex"/>
-                        </a:rPr>
-                        <a:t>8.4 s</a:t>
-                      </a:r>
-                    </a:p>
-                  </a:txBody>
-                  <a:tcPr marL="45720" marR="45720" marT="18288" marB="18288" anchor="ctr">
-                    <a:solidFill>
-                      <a:srgbClr val="FFFFFF"/>
-                    </a:solidFill>
-                  </a:tcPr>
-                </a:tc>
-              </a:tr>
-              <a:tr h="251460">
-                <a:tc>
-                  <a:txBody>
-                    <a:bodyPr/>
-                    <a:lstStyle/>
-                    <a:p>
-                      <a:pPr>
-                        <a:spcAft>
-                          <a:spcPts val="200"/>
-                        </a:spcAft>
-                      </a:pPr>
-                      <a:r>
-                        <a:rPr sz="850" b="1" i="0">
-                          <a:solidFill>
-                            <a:srgbClr val="202124"/>
-                          </a:solidFill>
-                          <a:latin typeface="Google Sans Flex"/>
-                          <a:ea typeface="Google Sans Flex"/>
-                          <a:cs typeface="Google Sans Flex"/>
-                          <a:sym typeface="Google Sans Flex"/>
-                        </a:rPr>
-                        <a:t>gpt-5.3-chat</a:t>
-                      </a:r>
-                    </a:p>
-                  </a:txBody>
-                  <a:tcPr marL="45720" marR="45720" marT="18288" marB="18288" anchor="ctr">
-                    <a:solidFill>
-                      <a:srgbClr val="F1F3F4"/>
-                    </a:solidFill>
-                  </a:tcPr>
-                </a:tc>
-                <a:tc>
-                  <a:txBody>
-                    <a:bodyPr/>
-                    <a:lstStyle/>
-                    <a:p>
-                      <a:pPr algn="ctr">
-                        <a:spcAft>
-                          <a:spcPts val="200"/>
-                        </a:spcAft>
-                      </a:pPr>
-                      <a:r>
-                        <a:rPr sz="850" b="0" i="0">
-                          <a:solidFill>
-                            <a:srgbClr val="202124"/>
-                          </a:solidFill>
-                          <a:latin typeface="Google Sans Flex"/>
-                          <a:ea typeface="Google Sans Flex"/>
-                          <a:cs typeface="Google Sans Flex"/>
-                          <a:sym typeface="Google Sans Flex"/>
-                        </a:rPr>
-                        <a:t>0.983</a:t>
-                      </a:r>
-                    </a:p>
-                  </a:txBody>
-                  <a:tcPr marL="45720" marR="45720" marT="18288" marB="18288" anchor="ctr">
-                    <a:solidFill>
-                      <a:srgbClr val="F1F3F4"/>
-                    </a:solidFill>
-                  </a:tcPr>
-                </a:tc>
-                <a:tc>
-                  <a:txBody>
-                    <a:bodyPr/>
-                    <a:lstStyle/>
-                    <a:p>
-                      <a:pPr algn="ctr">
-                        <a:spcAft>
-                          <a:spcPts val="200"/>
-                        </a:spcAft>
-                      </a:pPr>
-                      <a:r>
-                        <a:rPr sz="850" b="0" i="0">
-                          <a:solidFill>
-                            <a:srgbClr val="202124"/>
-                          </a:solidFill>
-                          <a:latin typeface="Google Sans Flex"/>
-                          <a:ea typeface="Google Sans Flex"/>
-                          <a:cs typeface="Google Sans Flex"/>
-                          <a:sym typeface="Google Sans Flex"/>
-                        </a:rPr>
-                        <a:t>97.5%</a:t>
-                      </a:r>
-                    </a:p>
-                  </a:txBody>
-                  <a:tcPr marL="45720" marR="45720" marT="18288" marB="18288" anchor="ctr">
-                    <a:solidFill>
-                      <a:srgbClr val="F1F3F4"/>
-                    </a:solidFill>
-                  </a:tcPr>
-                </a:tc>
-                <a:tc>
-                  <a:txBody>
-                    <a:bodyPr/>
-                    <a:lstStyle/>
-                    <a:p>
-                      <a:pPr algn="ctr">
-                        <a:spcAft>
-                          <a:spcPts val="200"/>
-                        </a:spcAft>
-                      </a:pPr>
-                      <a:r>
-                        <a:rPr sz="850" b="0" i="0">
-                          <a:solidFill>
-                            <a:srgbClr val="202124"/>
-                          </a:solidFill>
-                          <a:latin typeface="Google Sans Flex"/>
-                          <a:ea typeface="Google Sans Flex"/>
-                          <a:cs typeface="Google Sans Flex"/>
-                          <a:sym typeface="Google Sans Flex"/>
-                        </a:rPr>
-                        <a:t>100%</a:t>
-                      </a:r>
-                    </a:p>
-                  </a:txBody>
-                  <a:tcPr marL="45720" marR="45720" marT="18288" marB="18288" anchor="ctr">
-                    <a:solidFill>
-                      <a:srgbClr val="F1F3F4"/>
-                    </a:solidFill>
-                  </a:tcPr>
-                </a:tc>
-                <a:tc>
-                  <a:txBody>
-                    <a:bodyPr/>
-                    <a:lstStyle/>
-                    <a:p>
-                      <a:pPr algn="ctr">
-                        <a:spcAft>
-                          <a:spcPts val="200"/>
-                        </a:spcAft>
-                      </a:pPr>
-                      <a:r>
-                        <a:rPr sz="850" b="0" i="0">
-                          <a:solidFill>
-                            <a:srgbClr val="202124"/>
-                          </a:solidFill>
-                          <a:latin typeface="Google Sans Flex"/>
-                          <a:ea typeface="Google Sans Flex"/>
-                          <a:cs typeface="Google Sans Flex"/>
-                          <a:sym typeface="Google Sans Flex"/>
-                        </a:rPr>
-                        <a:t>21.5% (23.0%)</a:t>
-                      </a:r>
-                    </a:p>
-                  </a:txBody>
-                  <a:tcPr marL="45720" marR="45720" marT="18288" marB="18288" anchor="ctr">
-                    <a:solidFill>
-                      <a:srgbClr val="F1F3F4"/>
-                    </a:solidFill>
-                  </a:tcPr>
-                </a:tc>
-                <a:tc>
-                  <a:txBody>
-                    <a:bodyPr/>
-                    <a:lstStyle/>
-                    <a:p>
-                      <a:pPr algn="ctr">
-                        <a:spcAft>
-                          <a:spcPts val="200"/>
-                        </a:spcAft>
-                      </a:pPr>
-                      <a:r>
-                        <a:rPr sz="850" b="0" i="0">
-                          <a:solidFill>
-                            <a:srgbClr val="202124"/>
-                          </a:solidFill>
-                          <a:latin typeface="Google Sans Flex"/>
-                          <a:ea typeface="Google Sans Flex"/>
-                          <a:cs typeface="Google Sans Flex"/>
-                          <a:sym typeface="Google Sans Flex"/>
-                        </a:rPr>
-                        <a:t>21.6% (23.9%)</a:t>
-                      </a:r>
-                    </a:p>
-                  </a:txBody>
-                  <a:tcPr marL="45720" marR="45720" marT="18288" marB="18288" anchor="ctr">
-                    <a:solidFill>
-                      <a:srgbClr val="F1F3F4"/>
-                    </a:solidFill>
-                  </a:tcPr>
-                </a:tc>
-                <a:tc>
-                  <a:txBody>
-                    <a:bodyPr/>
-                    <a:lstStyle/>
-                    <a:p>
-                      <a:pPr algn="ctr">
-                        <a:spcAft>
-                          <a:spcPts val="200"/>
-                        </a:spcAft>
-                      </a:pPr>
-                      <a:r>
-                        <a:rPr sz="850" b="0" i="0">
-                          <a:solidFill>
-                            <a:srgbClr val="202124"/>
-                          </a:solidFill>
-                          <a:latin typeface="Google Sans Flex"/>
-                          <a:ea typeface="Google Sans Flex"/>
-                          <a:cs typeface="Google Sans Flex"/>
-                          <a:sym typeface="Google Sans Flex"/>
-                        </a:rPr>
-                        <a:t>0/6 (0)</a:t>
-                      </a:r>
-                    </a:p>
-                  </a:txBody>
-                  <a:tcPr marL="45720" marR="45720" marT="18288" marB="18288" anchor="ctr">
-                    <a:solidFill>
-                      <a:srgbClr val="F1F3F4"/>
-                    </a:solidFill>
-                  </a:tcPr>
-                </a:tc>
-                <a:tc>
-                  <a:txBody>
-                    <a:bodyPr/>
-                    <a:lstStyle/>
-                    <a:p>
-                      <a:pPr algn="ctr">
-                        <a:spcAft>
-                          <a:spcPts val="200"/>
-                        </a:spcAft>
-                      </a:pPr>
-                      <a:r>
-                        <a:rPr sz="850" b="0" i="0">
-                          <a:solidFill>
-                            <a:srgbClr val="202124"/>
-                          </a:solidFill>
-                          <a:latin typeface="Google Sans Flex"/>
-                          <a:ea typeface="Google Sans Flex"/>
-                          <a:cs typeface="Google Sans Flex"/>
-                          <a:sym typeface="Google Sans Flex"/>
-                        </a:rPr>
-                        <a:t>–</a:t>
-                      </a:r>
-                    </a:p>
-                  </a:txBody>
-                  <a:tcPr marL="45720" marR="45720" marT="18288" marB="18288" anchor="ctr">
-                    <a:solidFill>
-                      <a:srgbClr val="F1F3F4"/>
-                    </a:solidFill>
-                  </a:tcPr>
-                </a:tc>
-              </a:tr>
-              <a:tr h="251460">
-                <a:tc>
-                  <a:txBody>
-                    <a:bodyPr/>
-                    <a:lstStyle/>
-                    <a:p>
-                      <a:pPr>
-                        <a:spcAft>
-                          <a:spcPts val="200"/>
-                        </a:spcAft>
-                      </a:pPr>
-                      <a:r>
-                        <a:rPr sz="850" b="1" i="0">
-                          <a:solidFill>
-                            <a:srgbClr val="202124"/>
-                          </a:solidFill>
-                          <a:latin typeface="Google Sans Flex"/>
-                          <a:ea typeface="Google Sans Flex"/>
-                          <a:cs typeface="Google Sans Flex"/>
-                          <a:sym typeface="Google Sans Flex"/>
-                        </a:rPr>
-                        <a:t>gpt-5.4-mini</a:t>
-                      </a:r>
-                    </a:p>
-                  </a:txBody>
-                  <a:tcPr marL="45720" marR="45720" marT="18288" marB="18288" anchor="ctr">
-                    <a:solidFill>
-                      <a:srgbClr val="FFFFFF"/>
-                    </a:solidFill>
-                  </a:tcPr>
-                </a:tc>
-                <a:tc>
-                  <a:txBody>
-                    <a:bodyPr/>
-                    <a:lstStyle/>
-                    <a:p>
-                      <a:pPr algn="ctr">
-                        <a:spcAft>
-                          <a:spcPts val="200"/>
-                        </a:spcAft>
-                      </a:pPr>
-                      <a:r>
-                        <a:rPr sz="850" b="0" i="0">
-                          <a:solidFill>
-                            <a:srgbClr val="202124"/>
-                          </a:solidFill>
-                          <a:latin typeface="Google Sans Flex"/>
-                          <a:ea typeface="Google Sans Flex"/>
-                          <a:cs typeface="Google Sans Flex"/>
-                          <a:sym typeface="Google Sans Flex"/>
-                        </a:rPr>
-                        <a:t>0.968</a:t>
-                      </a:r>
-                    </a:p>
-                  </a:txBody>
-                  <a:tcPr marL="45720" marR="45720" marT="18288" marB="18288" anchor="ctr">
-                    <a:solidFill>
-                      <a:srgbClr val="FFFFFF"/>
-                    </a:solidFill>
-                  </a:tcPr>
-                </a:tc>
-                <a:tc>
-                  <a:txBody>
-                    <a:bodyPr/>
-                    <a:lstStyle/>
-                    <a:p>
-                      <a:pPr algn="ctr">
-                        <a:spcAft>
-                          <a:spcPts val="200"/>
-                        </a:spcAft>
-                      </a:pPr>
-                      <a:r>
-                        <a:rPr sz="850" b="0" i="0">
-                          <a:solidFill>
-                            <a:srgbClr val="202124"/>
-                          </a:solidFill>
-                          <a:latin typeface="Google Sans Flex"/>
-                          <a:ea typeface="Google Sans Flex"/>
-                          <a:cs typeface="Google Sans Flex"/>
-                          <a:sym typeface="Google Sans Flex"/>
-                        </a:rPr>
-                        <a:t>95.0%</a:t>
-                      </a:r>
-                    </a:p>
-                  </a:txBody>
-                  <a:tcPr marL="45720" marR="45720" marT="18288" marB="18288" anchor="ctr">
-                    <a:solidFill>
-                      <a:srgbClr val="FFFFFF"/>
-                    </a:solidFill>
-                  </a:tcPr>
-                </a:tc>
-                <a:tc>
-                  <a:txBody>
-                    <a:bodyPr/>
-                    <a:lstStyle/>
-                    <a:p>
-                      <a:pPr algn="ctr">
-                        <a:spcAft>
-                          <a:spcPts val="200"/>
-                        </a:spcAft>
-                      </a:pPr>
-                      <a:r>
-                        <a:rPr sz="850" b="0" i="0">
-                          <a:solidFill>
-                            <a:srgbClr val="202124"/>
-                          </a:solidFill>
-                          <a:latin typeface="Google Sans Flex"/>
-                          <a:ea typeface="Google Sans Flex"/>
-                          <a:cs typeface="Google Sans Flex"/>
-                          <a:sym typeface="Google Sans Flex"/>
-                        </a:rPr>
-                        <a:t>100%</a:t>
-                      </a:r>
-                    </a:p>
-                  </a:txBody>
-                  <a:tcPr marL="45720" marR="45720" marT="18288" marB="18288" anchor="ctr">
-                    <a:solidFill>
-                      <a:srgbClr val="FFFFFF"/>
-                    </a:solidFill>
-                  </a:tcPr>
-                </a:tc>
-                <a:tc>
-                  <a:txBody>
-                    <a:bodyPr/>
-                    <a:lstStyle/>
-                    <a:p>
-                      <a:pPr algn="ctr">
-                        <a:spcAft>
-                          <a:spcPts val="200"/>
-                        </a:spcAft>
-                      </a:pPr>
-                      <a:r>
-                        <a:rPr sz="850" b="0" i="0">
-                          <a:solidFill>
-                            <a:srgbClr val="202124"/>
-                          </a:solidFill>
-                          <a:latin typeface="Google Sans Flex"/>
-                          <a:ea typeface="Google Sans Flex"/>
-                          <a:cs typeface="Google Sans Flex"/>
-                          <a:sym typeface="Google Sans Flex"/>
-                        </a:rPr>
-                        <a:t>21.5% (23.1%)</a:t>
-                      </a:r>
-                    </a:p>
-                  </a:txBody>
-                  <a:tcPr marL="45720" marR="45720" marT="18288" marB="18288" anchor="ctr">
-                    <a:solidFill>
-                      <a:srgbClr val="FFFFFF"/>
-                    </a:solidFill>
-                  </a:tcPr>
-                </a:tc>
-                <a:tc>
-                  <a:txBody>
-                    <a:bodyPr/>
-                    <a:lstStyle/>
-                    <a:p>
-                      <a:pPr algn="ctr">
-                        <a:spcAft>
-                          <a:spcPts val="200"/>
-                        </a:spcAft>
-                      </a:pPr>
-                      <a:r>
-                        <a:rPr sz="850" b="0" i="0">
-                          <a:solidFill>
-                            <a:srgbClr val="202124"/>
-                          </a:solidFill>
-                          <a:latin typeface="Google Sans Flex"/>
-                          <a:ea typeface="Google Sans Flex"/>
-                          <a:cs typeface="Google Sans Flex"/>
-                          <a:sym typeface="Google Sans Flex"/>
-                        </a:rPr>
-                        <a:t>21.9% (24.2%)</a:t>
-                      </a:r>
-                    </a:p>
-                  </a:txBody>
-                  <a:tcPr marL="45720" marR="45720" marT="18288" marB="18288" anchor="ctr">
-                    <a:solidFill>
-                      <a:srgbClr val="FFFFFF"/>
-                    </a:solidFill>
-                  </a:tcPr>
-                </a:tc>
-                <a:tc>
-                  <a:txBody>
-                    <a:bodyPr/>
-                    <a:lstStyle/>
-                    <a:p>
-                      <a:pPr algn="ctr">
-                        <a:spcAft>
-                          <a:spcPts val="200"/>
-                        </a:spcAft>
-                      </a:pPr>
-                      <a:r>
-                        <a:rPr sz="850" b="0" i="0">
-                          <a:solidFill>
-                            <a:srgbClr val="202124"/>
-                          </a:solidFill>
-                          <a:latin typeface="Google Sans Flex"/>
-                          <a:ea typeface="Google Sans Flex"/>
-                          <a:cs typeface="Google Sans Flex"/>
-                          <a:sym typeface="Google Sans Flex"/>
-                        </a:rPr>
-                        <a:t>6/6 (5)</a:t>
-                      </a:r>
-                    </a:p>
-                  </a:txBody>
-                  <a:tcPr marL="45720" marR="45720" marT="18288" marB="18288" anchor="ctr">
-                    <a:solidFill>
-                      <a:srgbClr val="FFFFFF"/>
-                    </a:solidFill>
-                  </a:tcPr>
-                </a:tc>
-                <a:tc>
-                  <a:txBody>
-                    <a:bodyPr/>
-                    <a:lstStyle/>
-                    <a:p>
-                      <a:pPr algn="ctr">
-                        <a:spcAft>
-                          <a:spcPts val="200"/>
-                        </a:spcAft>
-                      </a:pPr>
-                      <a:r>
-                        <a:rPr sz="850" b="0" i="0">
-                          <a:solidFill>
-                            <a:srgbClr val="202124"/>
-                          </a:solidFill>
-                          <a:latin typeface="Google Sans Flex"/>
-                          <a:ea typeface="Google Sans Flex"/>
-                          <a:cs typeface="Google Sans Flex"/>
-                          <a:sym typeface="Google Sans Flex"/>
-                        </a:rPr>
-                        <a:t>3.9 s</a:t>
-                      </a:r>
-                    </a:p>
-                  </a:txBody>
-                  <a:tcPr marL="45720" marR="45720" marT="18288" marB="18288" anchor="ctr">
+                  <a:tcPr marL="64008" marR="64008" marT="27432" marB="27432" anchor="ctr">
                     <a:solidFill>
                       <a:srgbClr val="FFFFFF"/>
                     </a:solidFill>
@@ -14763,8 +12587,8 @@
         </p:nvSpPr>
         <p:spPr>
           <a:xfrm>
-            <a:off x="320040" y="4224528"/>
-            <a:ext cx="8503920" cy="685800"/>
+            <a:off x="320040" y="4160520"/>
+            <a:ext cx="8503920" cy="731520"/>
           </a:xfrm>
           <a:prstGeom prst="rect">
             <a:avLst/>
@@ -14792,7 +12616,7 @@
                 <a:cs typeface="Google Sans Flex"/>
                 <a:sym typeface="Google Sans Flex"/>
               </a:rPr>
-              <a:t>Every model beats the statistical forecast</a:t>
+              <a:t>Why gemini-3.5-flash-lite:</a:t>
             </a:r>
             <a:r>
               <a:rPr sz="850" b="0" i="0">
@@ -14804,7 +12628,7 @@
                 <a:cs typeface="Google Sans Flex"/>
                 <a:sym typeface="Google Sans Flex"/>
               </a:rPr>
-              <a:t> (by 1.7–4.9 pp on text-only series); extraction is near saturated (38–40 of 40 messages). gemini-3.5-flash-lite (Gemini API) is the default: as fast as the quickest model and 6 / 6 assistant answers checked; a stronger model could run the overnight forecasts.</a:t>
+              <a:t> fast (median assistant answer 4.0 s, tool calls included), every output passes the validators, and it fits the AI Studio free tier (15 requests a minute). Every call is logged with its status; a failed check falls back to a labelled non-LLM result.</a:t>
             </a:r>
           </a:p>
           <a:p>
@@ -14814,7 +12638,7 @@
               </a:spcAft>
             </a:pPr>
             <a:r>
-              <a:rPr sz="850" b="0" i="0">
+              <a:rPr sz="850" b="1" i="0">
                 <a:solidFill>
                   <a:srgbClr val="5F6368"/>
                 </a:solidFill>
@@ -14823,7 +12647,19 @@
                 <a:cs typeface="Google Sans Flex"/>
                 <a:sym typeface="Google Sans Flex"/>
               </a:rPr>
-              <a:t>Signal value kept: share of the gold-signal plan gain kept by plans built from the model's signals (found and fixed an end-date bug: −17% → 100%). gpt-5.3-chat's gateway rejects tool calls. Larger Gemini models need a paid key (free tier: 20 requests a day).</a:t>
+              <a:t>Next:</a:t>
+            </a:r>
+            <a:r>
+              <a:rPr sz="850" b="0" i="0">
+                <a:solidFill>
+                  <a:srgbClr val="5F6368"/>
+                </a:solidFill>
+                <a:latin typeface="Google Sans Flex"/>
+                <a:ea typeface="Google Sans Flex"/>
+                <a:cs typeface="Google Sans Flex"/>
+                <a:sym typeface="Google Sans Flex"/>
+              </a:rPr>
+              <a:t> larger Gemini models (gemini-3.8-flash) on a billing-enabled key; the free tier allows 20 requests a day and one evaluation run needs about 130. Small sets: 40 messages, 75 forecasts, 6 questions, so gaps under about 0.5 pp WAPE are noise.</a:t>
             </a:r>
           </a:p>
         </p:txBody>
@@ -28081,7 +25917,7 @@
                 <a:cs typeface="Google Sans Flex"/>
                 <a:sym typeface="Google Sans Flex"/>
               </a:rPr>
-              <a:t>deploy.sh (no local Docker)  ➜  </a:t>
+              <a:t>deploy.sh (gcloud CLI)  ➜  </a:t>
             </a:r>
             <a:r>
               <a:rPr sz="750" b="1" i="0">
@@ -28991,7 +26827,7 @@
                           <a:cs typeface="Google Sans Flex"/>
                           <a:sym typeface="Google Sans Flex"/>
                         </a:rPr>
-                        <a:t>pytest (160 tests), oxlint, strict TypeScript, LLM call log</a:t>
+                        <a:t>pytest (157 tests), oxlint, strict TypeScript, LLM call log</a:t>
                       </a:r>
                     </a:p>
                   </a:txBody>

</xml_diff>

<commit_message>
Deck: snapshot slide shows the new Simple view
Four phone-width screens as one flow: home, how to buy with the keep-aside slider, the plan list, and a Gemini answer.
</commit_message>
<xml_diff>
--- a/docs/Inventory_Rescue_AI_Builder_Cup.pptx
+++ b/docs/Inventory_Rescue_AI_Builder_Cup.pptx
@@ -8712,7 +8712,7 @@
                 <a:cs typeface="Google Sans Flex Medium"/>
                 <a:sym typeface="Google Sans Flex Medium"/>
               </a:rPr>
-              <a:t>Snapshots of the prototype</a:t>
+              <a:t>Snapshots of the prototype: the Simple view</a:t>
             </a:r>
             <a:endParaRPr sz="1600">
               <a:latin typeface="Google Sans Flex Medium"/>
@@ -8725,7 +8725,7 @@
       </p:sp>
       <p:pic>
         <p:nvPicPr>
-          <p:cNvPr id="136" name="Picture 135" descr="crop_0_plan.png"/>
+          <p:cNvPr id="136" name="Picture 135" descr="crop_0_s_home.png"/>
           <p:cNvPicPr>
             <a:picLocks noChangeAspect="1"/>
           </p:cNvPicPr>
@@ -8739,8 +8739,8 @@
         </p:blipFill>
         <p:spPr>
           <a:xfrm>
-            <a:off x="320040" y="1291414"/>
-            <a:ext cx="4160520" cy="1477107"/>
+            <a:off x="428693" y="1115568"/>
+            <a:ext cx="1771512" cy="3063240"/>
           </a:xfrm>
           <a:prstGeom prst="rect">
             <a:avLst/>
@@ -8760,8 +8760,8 @@
         </p:nvSpPr>
         <p:spPr>
           <a:xfrm>
-            <a:off x="320040" y="2907791"/>
-            <a:ext cx="4160520" cy="201168"/>
+            <a:off x="320040" y="4233672"/>
+            <a:ext cx="1988820" cy="365760"/>
           </a:xfrm>
           <a:prstGeom prst="rect">
             <a:avLst/>
@@ -8774,13 +8774,13 @@
           </a:bodyPr>
           <a:lstStyle/>
           <a:p>
-            <a:pPr>
+            <a:pPr algn="ctr">
               <a:spcAft>
                 <a:spcPts val="200"/>
               </a:spcAft>
             </a:pPr>
             <a:r>
-              <a:rPr sz="800" b="0" i="0">
+              <a:rPr sz="850" b="0" i="0">
                 <a:solidFill>
                   <a:srgbClr val="5F6368"/>
                 </a:solidFill>
@@ -8789,14 +8789,58 @@
                 <a:cs typeface="Google Sans Flex"/>
                 <a:sym typeface="Google Sans Flex"/>
               </a:rPr>
-              <a:t>Plan options: the same ₹10 lakh four ways, tested in calm and shocked futures</a:t>
-            </a:r>
+              <a:t>1. Three big buttons. Nothing else to learn.</a:t>
+            </a:r>
+          </a:p>
+        </p:txBody>
+      </p:sp>
+      <p:sp>
+        <p:nvSpPr>
+          <p:cNvPr id="138" name="Right Arrow 137"/>
+          <p:cNvSpPr/>
+          <p:nvPr/>
+        </p:nvSpPr>
+        <p:spPr>
+          <a:xfrm>
+            <a:off x="2336292" y="2574036"/>
+            <a:ext cx="128016" cy="146304"/>
+          </a:xfrm>
+          <a:prstGeom prst="rightArrow">
+            <a:avLst/>
+          </a:prstGeom>
+          <a:solidFill>
+            <a:srgbClr val="9AA0A6"/>
+          </a:solidFill>
+          <a:ln>
+            <a:noFill/>
+          </a:ln>
+          <a:effectLst/>
+        </p:spPr>
+        <p:style>
+          <a:lnRef idx="1">
+            <a:schemeClr val="accent1"/>
+          </a:lnRef>
+          <a:fillRef idx="3">
+            <a:schemeClr val="accent1"/>
+          </a:fillRef>
+          <a:effectRef idx="2">
+            <a:schemeClr val="accent1"/>
+          </a:effectRef>
+          <a:fontRef idx="minor">
+            <a:schemeClr val="lt1"/>
+          </a:fontRef>
+        </p:style>
+        <p:txBody>
+          <a:bodyPr rtlCol="0" anchor="t" wrap="square" lIns="73152" rIns="73152" tIns="73152" bIns="73152"/>
+          <a:lstStyle/>
+          <a:p>
+            <a:pPr algn="ctr"/>
           </a:p>
         </p:txBody>
       </p:sp>
       <p:pic>
         <p:nvPicPr>
-          <p:cNvPr id="138" name="Picture 137" descr="crop_1_assistant.png"/>
+          <p:cNvPr id="139" name="Picture 138" descr="crop_1_s_plan.png"/>
           <p:cNvPicPr>
             <a:picLocks noChangeAspect="1"/>
           </p:cNvPicPr>
@@ -8810,8 +8854,8 @@
         </p:blipFill>
         <p:spPr>
           <a:xfrm>
-            <a:off x="4663440" y="1193875"/>
-            <a:ext cx="4160520" cy="1672185"/>
+            <a:off x="2600393" y="1115568"/>
+            <a:ext cx="1771512" cy="3063240"/>
           </a:xfrm>
           <a:prstGeom prst="rect">
             <a:avLst/>
@@ -8825,14 +8869,14 @@
       </p:pic>
       <p:sp>
         <p:nvSpPr>
-          <p:cNvPr id="139" name="TextBox 138"/>
+          <p:cNvPr id="140" name="TextBox 139"/>
           <p:cNvSpPr txBox="1"/>
           <p:nvPr/>
         </p:nvSpPr>
         <p:spPr>
           <a:xfrm>
-            <a:off x="4663440" y="2907791"/>
-            <a:ext cx="4160520" cy="201168"/>
+            <a:off x="2491740" y="4233672"/>
+            <a:ext cx="1988820" cy="365760"/>
           </a:xfrm>
           <a:prstGeom prst="rect">
             <a:avLst/>
@@ -8845,13 +8889,13 @@
           </a:bodyPr>
           <a:lstStyle/>
           <a:p>
-            <a:pPr>
+            <a:pPr algn="ctr">
               <a:spcAft>
                 <a:spcPts val="200"/>
               </a:spcAft>
             </a:pPr>
             <a:r>
-              <a:rPr sz="800" b="0" i="0">
+              <a:rPr sz="850" b="0" i="0">
                 <a:solidFill>
                   <a:srgbClr val="5F6368"/>
                 </a:solidFill>
@@ -8860,14 +8904,58 @@
                 <a:cs typeface="Google Sans Flex"/>
                 <a:sym typeface="Google Sans Flex"/>
               </a:rPr>
-              <a:t>Planning assistant: “10 lakh vs 15 lakh?” answered from a planner tool; 34 values checked</a:t>
-            </a:r>
+              <a:t>2. Type a budget; choose how to buy and how much to keep aside.</a:t>
+            </a:r>
+          </a:p>
+        </p:txBody>
+      </p:sp>
+      <p:sp>
+        <p:nvSpPr>
+          <p:cNvPr id="141" name="Right Arrow 140"/>
+          <p:cNvSpPr/>
+          <p:nvPr/>
+        </p:nvSpPr>
+        <p:spPr>
+          <a:xfrm>
+            <a:off x="4507992" y="2574036"/>
+            <a:ext cx="128016" cy="146304"/>
+          </a:xfrm>
+          <a:prstGeom prst="rightArrow">
+            <a:avLst/>
+          </a:prstGeom>
+          <a:solidFill>
+            <a:srgbClr val="9AA0A6"/>
+          </a:solidFill>
+          <a:ln>
+            <a:noFill/>
+          </a:ln>
+          <a:effectLst/>
+        </p:spPr>
+        <p:style>
+          <a:lnRef idx="1">
+            <a:schemeClr val="accent1"/>
+          </a:lnRef>
+          <a:fillRef idx="3">
+            <a:schemeClr val="accent1"/>
+          </a:fillRef>
+          <a:effectRef idx="2">
+            <a:schemeClr val="accent1"/>
+          </a:effectRef>
+          <a:fontRef idx="minor">
+            <a:schemeClr val="lt1"/>
+          </a:fontRef>
+        </p:style>
+        <p:txBody>
+          <a:bodyPr rtlCol="0" anchor="t" wrap="square" lIns="73152" rIns="73152" tIns="73152" bIns="73152"/>
+          <a:lstStyle/>
+          <a:p>
+            <a:pPr algn="ctr"/>
           </a:p>
         </p:txBody>
       </p:sp>
       <p:pic>
         <p:nvPicPr>
-          <p:cNvPr id="140" name="Picture 139" descr="crop_2_simple.png"/>
+          <p:cNvPr id="142" name="Picture 141" descr="crop_2_s_plan.png"/>
           <p:cNvPicPr>
             <a:picLocks noChangeAspect="1"/>
           </p:cNvPicPr>
@@ -8881,8 +8969,8 @@
         </p:blipFill>
         <p:spPr>
           <a:xfrm>
-            <a:off x="320040" y="3157038"/>
-            <a:ext cx="4160520" cy="1549763"/>
+            <a:off x="4772093" y="1115568"/>
+            <a:ext cx="1771512" cy="3063240"/>
           </a:xfrm>
           <a:prstGeom prst="rect">
             <a:avLst/>
@@ -8896,14 +8984,14 @@
       </p:pic>
       <p:sp>
         <p:nvSpPr>
-          <p:cNvPr id="141" name="TextBox 140"/>
+          <p:cNvPr id="143" name="TextBox 142"/>
           <p:cNvSpPr txBox="1"/>
           <p:nvPr/>
         </p:nvSpPr>
         <p:spPr>
           <a:xfrm>
-            <a:off x="320040" y="4809744"/>
-            <a:ext cx="4160520" cy="201168"/>
+            <a:off x="4663440" y="4233672"/>
+            <a:ext cx="1988820" cy="365760"/>
           </a:xfrm>
           <a:prstGeom prst="rect">
             <a:avLst/>
@@ -8916,13 +9004,13 @@
           </a:bodyPr>
           <a:lstStyle/>
           <a:p>
-            <a:pPr>
+            <a:pPr algn="ctr">
               <a:spcAft>
                 <a:spcPts val="200"/>
               </a:spcAft>
             </a:pPr>
             <a:r>
-              <a:rPr sz="800" b="0" i="0">
+              <a:rPr sz="850" b="0" i="0">
                 <a:solidFill>
                   <a:srgbClr val="5F6368"/>
                 </a:solidFill>
@@ -8931,14 +9019,58 @@
                 <a:cs typeface="Google Sans Flex"/>
                 <a:sym typeface="Google Sans Flex"/>
               </a:rPr>
-              <a:t>Simple view (default): three big buttons; budget, then how to buy</a:t>
-            </a:r>
+              <a:t>3. A plain to-do list: what to buy, by when, and why.</a:t>
+            </a:r>
+          </a:p>
+        </p:txBody>
+      </p:sp>
+      <p:sp>
+        <p:nvSpPr>
+          <p:cNvPr id="144" name="Right Arrow 143"/>
+          <p:cNvSpPr/>
+          <p:nvPr/>
+        </p:nvSpPr>
+        <p:spPr>
+          <a:xfrm>
+            <a:off x="6679692" y="2574036"/>
+            <a:ext cx="128016" cy="146304"/>
+          </a:xfrm>
+          <a:prstGeom prst="rightArrow">
+            <a:avLst/>
+          </a:prstGeom>
+          <a:solidFill>
+            <a:srgbClr val="9AA0A6"/>
+          </a:solidFill>
+          <a:ln>
+            <a:noFill/>
+          </a:ln>
+          <a:effectLst/>
+        </p:spPr>
+        <p:style>
+          <a:lnRef idx="1">
+            <a:schemeClr val="accent1"/>
+          </a:lnRef>
+          <a:fillRef idx="3">
+            <a:schemeClr val="accent1"/>
+          </a:fillRef>
+          <a:effectRef idx="2">
+            <a:schemeClr val="accent1"/>
+          </a:effectRef>
+          <a:fontRef idx="minor">
+            <a:schemeClr val="lt1"/>
+          </a:fontRef>
+        </p:style>
+        <p:txBody>
+          <a:bodyPr rtlCol="0" anchor="t" wrap="square" lIns="73152" rIns="73152" tIns="73152" bIns="73152"/>
+          <a:lstStyle/>
+          <a:p>
+            <a:pPr algn="ctr"/>
           </a:p>
         </p:txBody>
       </p:sp>
       <p:pic>
         <p:nvPicPr>
-          <p:cNvPr id="142" name="Picture 141" descr="crop_3_plan.png"/>
+          <p:cNvPr id="145" name="Picture 144" descr="crop_3_s_ask.png"/>
           <p:cNvPicPr>
             <a:picLocks noChangeAspect="1"/>
           </p:cNvPicPr>
@@ -8952,8 +9084,8 @@
         </p:blipFill>
         <p:spPr>
           <a:xfrm>
-            <a:off x="4663440" y="3531870"/>
-            <a:ext cx="4160520" cy="800099"/>
+            <a:off x="6943793" y="1115568"/>
+            <a:ext cx="1771512" cy="3063240"/>
           </a:xfrm>
           <a:prstGeom prst="rect">
             <a:avLst/>
@@ -8967,14 +9099,14 @@
       </p:pic>
       <p:sp>
         <p:nvSpPr>
-          <p:cNvPr id="143" name="TextBox 142"/>
+          <p:cNvPr id="146" name="TextBox 145"/>
           <p:cNvSpPr txBox="1"/>
           <p:nvPr/>
         </p:nvSpPr>
         <p:spPr>
           <a:xfrm>
-            <a:off x="4663440" y="4809744"/>
-            <a:ext cx="4160520" cy="201168"/>
+            <a:off x="6835140" y="4233672"/>
+            <a:ext cx="1988820" cy="365760"/>
           </a:xfrm>
           <a:prstGeom prst="rect">
             <a:avLst/>
@@ -8987,13 +9119,13 @@
           </a:bodyPr>
           <a:lstStyle/>
           <a:p>
-            <a:pPr>
+            <a:pPr algn="ctr">
               <a:spcAft>
                 <a:spcPts val="200"/>
               </a:spcAft>
             </a:pPr>
             <a:r>
-              <a:rPr sz="800" b="0" i="0">
+              <a:rPr sz="850" b="0" i="0">
                 <a:solidFill>
                   <a:srgbClr val="5F6368"/>
                 </a:solidFill>
@@ -9002,7 +9134,49 @@
                 <a:cs typeface="Google Sans Flex"/>
                 <a:sym typeface="Google Sans Flex"/>
               </a:rPr>
-              <a:t>Robustness: 120 simulated futures vs reorder rules; weekly re-planning</a:t>
+              <a:t>4. Ask in your own words; Gemini answers from checked numbers.</a:t>
+            </a:r>
+          </a:p>
+        </p:txBody>
+      </p:sp>
+      <p:sp>
+        <p:nvSpPr>
+          <p:cNvPr id="147" name="TextBox 146"/>
+          <p:cNvSpPr txBox="1"/>
+          <p:nvPr/>
+        </p:nvSpPr>
+        <p:spPr>
+          <a:xfrm>
+            <a:off x="320040" y="4681728"/>
+            <a:ext cx="8503920" cy="228600"/>
+          </a:xfrm>
+          <a:prstGeom prst="rect">
+            <a:avLst/>
+          </a:prstGeom>
+          <a:noFill/>
+        </p:spPr>
+        <p:txBody>
+          <a:bodyPr wrap="square" anchor="t" lIns="0" rIns="0" tIns="0" bIns="0">
+            <a:spAutoFit/>
+          </a:bodyPr>
+          <a:lstStyle/>
+          <a:p>
+            <a:pPr algn="ctr">
+              <a:spcAft>
+                <a:spcPts val="200"/>
+              </a:spcAft>
+            </a:pPr>
+            <a:r>
+              <a:rPr sz="800" b="0" i="0">
+                <a:solidFill>
+                  <a:srgbClr val="5F6368"/>
+                </a:solidFill>
+                <a:latin typeface="Google Sans Flex"/>
+                <a:ea typeface="Google Sans Flex"/>
+                <a:cs typeface="Google Sans Flex"/>
+                <a:sym typeface="Google Sans Flex"/>
+              </a:rPr>
+              <a:t>Default screen for first-time users. Charts, robustness tests and every number behind the plan stay one click away in the Advanced view.</a:t>
             </a:r>
           </a:p>
         </p:txBody>

</xml_diff>

<commit_message>
Assistant: run-out dates match the plan
- New list_stockouts tool: run-out dates from the planning world (the plan screen's dates), earliest first, with and without the plan.
- Stockout alerts use the same planning-world date and no longer skip products that run out after an earlier open PO arrives.
- Prompt routes 'what runs out first' to list_stockouts; test added (158 passing).
- Deck: snapshot slide recaptured with the corrected answer; 11 tools, 158 tests.
</commit_message>
<xml_diff>
--- a/docs/Inventory_Rescue_AI_Builder_Cup.pptx
+++ b/docs/Inventory_Rescue_AI_Builder_Cup.pptx
@@ -9442,7 +9442,7 @@
                 <a:cs typeface="Google Sans Flex"/>
                 <a:sym typeface="Google Sans Flex"/>
               </a:rPr>
-              <a:t> 157 automated tests pass · 30 / 30 seed forecasts passed LLM validation · every LLM call logged with its status.</a:t>
+              <a:t> 158 automated tests pass · 30 / 30 seed forecasts passed LLM validation · every LLM call logged with its status.</a:t>
             </a:r>
           </a:p>
         </p:txBody>
@@ -25447,7 +25447,7 @@
                 <a:cs typeface="Google Sans Flex"/>
                 <a:sym typeface="Google Sans Flex"/>
               </a:rPr>
-              <a:t>10 tools, numbers checked</a:t>
+              <a:t>11 tools, numbers checked</a:t>
             </a:r>
           </a:p>
         </p:txBody>
@@ -27001,7 +27001,7 @@
                           <a:cs typeface="Google Sans Flex"/>
                           <a:sym typeface="Google Sans Flex"/>
                         </a:rPr>
-                        <a:t>pytest (157 tests), oxlint, strict TypeScript, LLM call log</a:t>
+                        <a:t>pytest (158 tests), oxlint, strict TypeScript, LLM call log</a:t>
                       </a:r>
                     </a:p>
                   </a:txBody>

</xml_diff>